<commit_message>
fix(brand): pptx template — user corrections + wordmark casing
- Планометрика wordmark: single capital (8 replacements in slides)
- user edits kept: Unbounded Medium / JetBrains Mono Medium runs,
  title accent bars removed, contact mail@planometrica.ru
- generator mirrors the file (regen verified equivalent)

Co-Authored-By: Claude Fable 5 <noreply@anthropic.com>
</commit_message>
<xml_diff>
--- a/templates/planometrica-brand.pptx
+++ b/templates/planometrica-brand.pptx
@@ -5,17 +5,17 @@
     <p:sldMasterId id="2147483648" r:id="rId1"/>
   </p:sldMasterIdLst>
   <p:sldIdLst>
-    <p:sldId id="256" r:id="rId7"/>
-    <p:sldId id="257" r:id="rId8"/>
-    <p:sldId id="258" r:id="rId9"/>
-    <p:sldId id="259" r:id="rId10"/>
-    <p:sldId id="260" r:id="rId11"/>
-    <p:sldId id="261" r:id="rId12"/>
-    <p:sldId id="262" r:id="rId13"/>
-    <p:sldId id="263" r:id="rId14"/>
-    <p:sldId id="264" r:id="rId15"/>
+    <p:sldId id="256" r:id="rId2"/>
+    <p:sldId id="257" r:id="rId3"/>
+    <p:sldId id="258" r:id="rId4"/>
+    <p:sldId id="259" r:id="rId5"/>
+    <p:sldId id="260" r:id="rId6"/>
+    <p:sldId id="261" r:id="rId7"/>
+    <p:sldId id="262" r:id="rId8"/>
+    <p:sldId id="263" r:id="rId9"/>
+    <p:sldId id="264" r:id="rId10"/>
   </p:sldIdLst>
-  <p:sldSz cx="12191695" cy="6858000" type="screen4x3"/>
+  <p:sldSz cx="12192000" cy="6858000"/>
   <p:notesSz cx="6858000" cy="9144000"/>
   <p:defaultTextStyle>
     <a:defPPr>
@@ -112,19 +112,42 @@
       </a:defRPr>
     </a:lvl9pPr>
   </p:defaultTextStyle>
+  <p:extLst>
+    <p:ext uri="{EFAFB233-063F-42B5-8137-9DF3F51BA10A}">
+      <p15:sldGuideLst xmlns:p15="http://schemas.microsoft.com/office/powerpoint/2012/main">
+        <p15:guide id="1" orient="horz" pos="2160">
+          <p15:clr>
+            <a:srgbClr val="A4A3A4"/>
+          </p15:clr>
+        </p15:guide>
+        <p15:guide id="2" pos="2880">
+          <p15:clr>
+            <a:srgbClr val="A4A3A4"/>
+          </p15:clr>
+        </p15:guide>
+      </p15:sldGuideLst>
+    </p:ext>
+  </p:extLst>
 </p:presentation>
 </file>
 
 <file path=ppt/charts/chart1.xml><?xml version="1.0" encoding="utf-8"?>
-<c:chartSpace xmlns:c="http://schemas.openxmlformats.org/drawingml/2006/chart" xmlns:a="http://schemas.openxmlformats.org/drawingml/2006/main" xmlns:r="http://schemas.openxmlformats.org/officeDocument/2006/relationships">
+<c:chartSpace xmlns:c="http://schemas.openxmlformats.org/drawingml/2006/chart" xmlns:a="http://schemas.openxmlformats.org/drawingml/2006/main" xmlns:r="http://schemas.openxmlformats.org/officeDocument/2006/relationships" xmlns:c16r2="http://schemas.microsoft.com/office/drawing/2015/06/chart">
   <c:date1904 val="0"/>
+  <c:lang val="ru-RU"/>
+  <c:roundedCorners val="1"/>
+  <c:style val="2"/>
   <c:chart>
+    <c:title>
+      <c:overlay val="0"/>
+    </c:title>
     <c:autoTitleDeleted val="0"/>
     <c:plotArea>
+      <c:layout/>
       <c:barChart>
         <c:barDir val="col"/>
         <c:grouping val="clustered"/>
-        <c:varyColors/>
+        <c:varyColors val="1"/>
         <c:ser>
           <c:idx val="0"/>
           <c:order val="0"/>
@@ -139,45 +162,81 @@
               </c:strCache>
             </c:strRef>
           </c:tx>
+          <c:invertIfNegative val="1"/>
           <c:dPt>
             <c:idx val="0"/>
+            <c:invertIfNegative val="1"/>
+            <c:bubble3D val="0"/>
             <c:spPr>
               <a:solidFill>
                 <a:srgbClr val="0A4C76"/>
               </a:solidFill>
             </c:spPr>
+            <c:extLst>
+              <c:ext xmlns:c16="http://schemas.microsoft.com/office/drawing/2014/chart" uri="{C3380CC4-5D6E-409C-BE32-E72D297353CC}">
+                <c16:uniqueId val="{00000001-79B2-C44E-9759-D94DB579FE26}"/>
+              </c:ext>
+            </c:extLst>
           </c:dPt>
           <c:dPt>
             <c:idx val="1"/>
+            <c:invertIfNegative val="1"/>
+            <c:bubble3D val="0"/>
             <c:spPr>
               <a:solidFill>
                 <a:srgbClr val="1A7BB3"/>
               </a:solidFill>
             </c:spPr>
+            <c:extLst>
+              <c:ext xmlns:c16="http://schemas.microsoft.com/office/drawing/2014/chart" uri="{C3380CC4-5D6E-409C-BE32-E72D297353CC}">
+                <c16:uniqueId val="{00000003-79B2-C44E-9759-D94DB579FE26}"/>
+              </c:ext>
+            </c:extLst>
           </c:dPt>
           <c:dPt>
             <c:idx val="2"/>
+            <c:invertIfNegative val="1"/>
+            <c:bubble3D val="0"/>
             <c:spPr>
               <a:solidFill>
                 <a:srgbClr val="92CF93"/>
               </a:solidFill>
             </c:spPr>
+            <c:extLst>
+              <c:ext xmlns:c16="http://schemas.microsoft.com/office/drawing/2014/chart" uri="{C3380CC4-5D6E-409C-BE32-E72D297353CC}">
+                <c16:uniqueId val="{00000005-79B2-C44E-9759-D94DB579FE26}"/>
+              </c:ext>
+            </c:extLst>
           </c:dPt>
           <c:dPt>
             <c:idx val="3"/>
+            <c:invertIfNegative val="1"/>
+            <c:bubble3D val="0"/>
             <c:spPr>
               <a:solidFill>
                 <a:srgbClr val="F59E0B"/>
               </a:solidFill>
             </c:spPr>
+            <c:extLst>
+              <c:ext xmlns:c16="http://schemas.microsoft.com/office/drawing/2014/chart" uri="{C3380CC4-5D6E-409C-BE32-E72D297353CC}">
+                <c16:uniqueId val="{00000007-79B2-C44E-9759-D94DB579FE26}"/>
+              </c:ext>
+            </c:extLst>
           </c:dPt>
           <c:dPt>
             <c:idx val="4"/>
+            <c:invertIfNegative val="1"/>
+            <c:bubble3D val="0"/>
             <c:spPr>
               <a:solidFill>
                 <a:srgbClr val="EF4444"/>
               </a:solidFill>
             </c:spPr>
+            <c:extLst>
+              <c:ext xmlns:c16="http://schemas.microsoft.com/office/drawing/2014/chart" uri="{C3380CC4-5D6E-409C-BE32-E72D297353CC}">
+                <c16:uniqueId val="{00000009-79B2-C44E-9759-D94DB579FE26}"/>
+              </c:ext>
+            </c:extLst>
           </c:dPt>
           <c:cat>
             <c:strRef>
@@ -226,7 +285,21 @@
               </c:numCache>
             </c:numRef>
           </c:val>
+          <c:extLst>
+            <c:ext xmlns:c16="http://schemas.microsoft.com/office/drawing/2014/chart" uri="{C3380CC4-5D6E-409C-BE32-E72D297353CC}">
+              <c16:uniqueId val="{0000000A-79B2-C44E-9759-D94DB579FE26}"/>
+            </c:ext>
+          </c:extLst>
         </c:ser>
+        <c:dLbls>
+          <c:showLegendKey val="0"/>
+          <c:showVal val="0"/>
+          <c:showCatName val="0"/>
+          <c:showSerName val="0"/>
+          <c:showPercent val="0"/>
+          <c:showBubbleSize val="0"/>
+        </c:dLbls>
+        <c:gapWidth val="150"/>
         <c:axId val="-2068027336"/>
         <c:axId val="-2113994440"/>
       </c:barChart>
@@ -237,6 +310,7 @@
         </c:scaling>
         <c:delete val="0"/>
         <c:axPos val="b"/>
+        <c:numFmt formatCode="General" sourceLinked="0"/>
         <c:majorTickMark val="out"/>
         <c:minorTickMark val="none"/>
         <c:tickLblPos val="nextTo"/>
@@ -249,9 +323,10 @@
                 <a:solidFill>
                   <a:srgbClr val="64748B"/>
                 </a:solidFill>
-                <a:latin typeface="JetBrains Mono"/>
+                <a:latin typeface="JetBrains Mono Medium"/>
               </a:defRPr>
             </a:pPr>
+            <a:endParaRPr lang="ru-KZ"/>
           </a:p>
         </c:txPr>
         <c:crossAx val="-2113994440"/>
@@ -263,10 +338,13 @@
       </c:catAx>
       <c:valAx>
         <c:axId val="-2113994440"/>
-        <c:scaling/>
+        <c:scaling>
+          <c:orientation val="minMax"/>
+        </c:scaling>
         <c:delete val="0"/>
         <c:axPos val="l"/>
         <c:majorGridlines/>
+        <c:numFmt formatCode="General" sourceLinked="1"/>
         <c:majorTickMark val="out"/>
         <c:minorTickMark val="none"/>
         <c:tickLblPos val="nextTo"/>
@@ -279,16 +357,20 @@
                 <a:solidFill>
                   <a:srgbClr val="64748B"/>
                 </a:solidFill>
-                <a:latin typeface="JetBrains Mono"/>
+                <a:latin typeface="JetBrains Mono Medium"/>
               </a:defRPr>
             </a:pPr>
+            <a:endParaRPr lang="ru-KZ"/>
           </a:p>
         </c:txPr>
         <c:crossAx val="-2068027336"/>
         <c:crosses val="autoZero"/>
+        <c:crossBetween val="between"/>
       </c:valAx>
     </c:plotArea>
+    <c:plotVisOnly val="1"/>
     <c:dispBlanksAs val="gap"/>
+    <c:showDLblsOverMax val="1"/>
   </c:chart>
   <c:txPr>
     <a:bodyPr/>
@@ -344,10 +426,9 @@
           <a:lstStyle/>
           <a:p>
             <a:r>
-              <a:rPr lang="en-US" smtClean="0"/>
+              <a:rPr lang="en-US"/>
               <a:t>Click to edit Master title style</a:t>
             </a:r>
-            <a:endParaRPr lang="en-US"/>
           </a:p>
         </p:txBody>
       </p:sp>
@@ -463,10 +544,9 @@
           </a:lstStyle>
           <a:p>
             <a:r>
-              <a:rPr lang="en-US" smtClean="0"/>
+              <a:rPr lang="en-US"/>
               <a:t>Click to edit Master subtitle style</a:t>
             </a:r>
-            <a:endParaRPr lang="en-US"/>
           </a:p>
         </p:txBody>
       </p:sp>
@@ -487,7 +567,7 @@
           <a:p>
             <a:fld id="{5BCAD085-E8A6-8845-BD4E-CB4CCA059FC4}" type="datetimeFigureOut">
               <a:rPr lang="en-US" smtClean="0"/>
-              <a:t>1/27/13</a:t>
+              <a:t>7/13/26</a:t>
             </a:fld>
             <a:endParaRPr lang="en-US"/>
           </a:p>
@@ -581,10 +661,9 @@
           <a:lstStyle/>
           <a:p>
             <a:r>
-              <a:rPr lang="en-US" smtClean="0"/>
+              <a:rPr lang="en-US"/>
               <a:t>Click to edit Master title style</a:t>
             </a:r>
-            <a:endParaRPr lang="en-US"/>
           </a:p>
         </p:txBody>
       </p:sp>
@@ -605,38 +684,37 @@
           <a:p>
             <a:pPr lvl="0"/>
             <a:r>
-              <a:rPr lang="en-US" smtClean="0"/>
+              <a:rPr lang="en-US"/>
               <a:t>Click to edit Master text styles</a:t>
             </a:r>
           </a:p>
           <a:p>
             <a:pPr lvl="1"/>
             <a:r>
-              <a:rPr lang="en-US" smtClean="0"/>
+              <a:rPr lang="en-US"/>
               <a:t>Second level</a:t>
             </a:r>
           </a:p>
           <a:p>
             <a:pPr lvl="2"/>
             <a:r>
-              <a:rPr lang="en-US" smtClean="0"/>
+              <a:rPr lang="en-US"/>
               <a:t>Third level</a:t>
             </a:r>
           </a:p>
           <a:p>
             <a:pPr lvl="3"/>
             <a:r>
-              <a:rPr lang="en-US" smtClean="0"/>
+              <a:rPr lang="en-US"/>
               <a:t>Fourth level</a:t>
             </a:r>
           </a:p>
           <a:p>
             <a:pPr lvl="4"/>
             <a:r>
-              <a:rPr lang="en-US" smtClean="0"/>
+              <a:rPr lang="en-US"/>
               <a:t>Fifth level</a:t>
             </a:r>
-            <a:endParaRPr lang="en-US"/>
           </a:p>
         </p:txBody>
       </p:sp>
@@ -657,7 +735,7 @@
           <a:p>
             <a:fld id="{5BCAD085-E8A6-8845-BD4E-CB4CCA059FC4}" type="datetimeFigureOut">
               <a:rPr lang="en-US" smtClean="0"/>
-              <a:t>1/27/13</a:t>
+              <a:t>7/13/26</a:t>
             </a:fld>
             <a:endParaRPr lang="en-US"/>
           </a:p>
@@ -756,10 +834,9 @@
           <a:lstStyle/>
           <a:p>
             <a:r>
-              <a:rPr lang="en-US" smtClean="0"/>
+              <a:rPr lang="en-US"/>
               <a:t>Click to edit Master title style</a:t>
             </a:r>
-            <a:endParaRPr lang="en-US"/>
           </a:p>
         </p:txBody>
       </p:sp>
@@ -785,38 +862,37 @@
           <a:p>
             <a:pPr lvl="0"/>
             <a:r>
-              <a:rPr lang="en-US" smtClean="0"/>
+              <a:rPr lang="en-US"/>
               <a:t>Click to edit Master text styles</a:t>
             </a:r>
           </a:p>
           <a:p>
             <a:pPr lvl="1"/>
             <a:r>
-              <a:rPr lang="en-US" smtClean="0"/>
+              <a:rPr lang="en-US"/>
               <a:t>Second level</a:t>
             </a:r>
           </a:p>
           <a:p>
             <a:pPr lvl="2"/>
             <a:r>
-              <a:rPr lang="en-US" smtClean="0"/>
+              <a:rPr lang="en-US"/>
               <a:t>Third level</a:t>
             </a:r>
           </a:p>
           <a:p>
             <a:pPr lvl="3"/>
             <a:r>
-              <a:rPr lang="en-US" smtClean="0"/>
+              <a:rPr lang="en-US"/>
               <a:t>Fourth level</a:t>
             </a:r>
           </a:p>
           <a:p>
             <a:pPr lvl="4"/>
             <a:r>
-              <a:rPr lang="en-US" smtClean="0"/>
+              <a:rPr lang="en-US"/>
               <a:t>Fifth level</a:t>
             </a:r>
-            <a:endParaRPr lang="en-US"/>
           </a:p>
         </p:txBody>
       </p:sp>
@@ -837,7 +913,7 @@
           <a:p>
             <a:fld id="{5BCAD085-E8A6-8845-BD4E-CB4CCA059FC4}" type="datetimeFigureOut">
               <a:rPr lang="en-US" smtClean="0"/>
-              <a:t>1/27/13</a:t>
+              <a:t>7/13/26</a:t>
             </a:fld>
             <a:endParaRPr lang="en-US"/>
           </a:p>
@@ -931,10 +1007,9 @@
           <a:lstStyle/>
           <a:p>
             <a:r>
-              <a:rPr lang="en-US" smtClean="0"/>
+              <a:rPr lang="en-US"/>
               <a:t>Click to edit Master title style</a:t>
             </a:r>
-            <a:endParaRPr lang="en-US"/>
           </a:p>
         </p:txBody>
       </p:sp>
@@ -955,38 +1030,37 @@
           <a:p>
             <a:pPr lvl="0"/>
             <a:r>
-              <a:rPr lang="en-US" smtClean="0"/>
+              <a:rPr lang="en-US"/>
               <a:t>Click to edit Master text styles</a:t>
             </a:r>
           </a:p>
           <a:p>
             <a:pPr lvl="1"/>
             <a:r>
-              <a:rPr lang="en-US" smtClean="0"/>
+              <a:rPr lang="en-US"/>
               <a:t>Second level</a:t>
             </a:r>
           </a:p>
           <a:p>
             <a:pPr lvl="2"/>
             <a:r>
-              <a:rPr lang="en-US" smtClean="0"/>
+              <a:rPr lang="en-US"/>
               <a:t>Third level</a:t>
             </a:r>
           </a:p>
           <a:p>
             <a:pPr lvl="3"/>
             <a:r>
-              <a:rPr lang="en-US" smtClean="0"/>
+              <a:rPr lang="en-US"/>
               <a:t>Fourth level</a:t>
             </a:r>
           </a:p>
           <a:p>
             <a:pPr lvl="4"/>
             <a:r>
-              <a:rPr lang="en-US" smtClean="0"/>
+              <a:rPr lang="en-US"/>
               <a:t>Fifth level</a:t>
             </a:r>
-            <a:endParaRPr lang="en-US"/>
           </a:p>
         </p:txBody>
       </p:sp>
@@ -1007,7 +1081,7 @@
           <a:p>
             <a:fld id="{5BCAD085-E8A6-8845-BD4E-CB4CCA059FC4}" type="datetimeFigureOut">
               <a:rPr lang="en-US" smtClean="0"/>
-              <a:t>1/27/13</a:t>
+              <a:t>7/13/26</a:t>
             </a:fld>
             <a:endParaRPr lang="en-US"/>
           </a:p>
@@ -1110,10 +1184,9 @@
           </a:lstStyle>
           <a:p>
             <a:r>
-              <a:rPr lang="en-US" smtClean="0"/>
+              <a:rPr lang="en-US"/>
               <a:t>Click to edit Master title style</a:t>
             </a:r>
-            <a:endParaRPr lang="en-US"/>
           </a:p>
         </p:txBody>
       </p:sp>
@@ -1230,7 +1303,7 @@
           <a:p>
             <a:pPr lvl="0"/>
             <a:r>
-              <a:rPr lang="en-US" smtClean="0"/>
+              <a:rPr lang="en-US"/>
               <a:t>Click to edit Master text styles</a:t>
             </a:r>
           </a:p>
@@ -1253,7 +1326,7 @@
           <a:p>
             <a:fld id="{5BCAD085-E8A6-8845-BD4E-CB4CCA059FC4}" type="datetimeFigureOut">
               <a:rPr lang="en-US" smtClean="0"/>
-              <a:t>1/27/13</a:t>
+              <a:t>7/13/26</a:t>
             </a:fld>
             <a:endParaRPr lang="en-US"/>
           </a:p>
@@ -1347,10 +1420,9 @@
           <a:lstStyle/>
           <a:p>
             <a:r>
-              <a:rPr lang="en-US" smtClean="0"/>
+              <a:rPr lang="en-US"/>
               <a:t>Click to edit Master title style</a:t>
             </a:r>
-            <a:endParaRPr lang="en-US"/>
           </a:p>
         </p:txBody>
       </p:sp>
@@ -1404,38 +1476,37 @@
           <a:p>
             <a:pPr lvl="0"/>
             <a:r>
-              <a:rPr lang="en-US" smtClean="0"/>
+              <a:rPr lang="en-US"/>
               <a:t>Click to edit Master text styles</a:t>
             </a:r>
           </a:p>
           <a:p>
             <a:pPr lvl="1"/>
             <a:r>
-              <a:rPr lang="en-US" smtClean="0"/>
+              <a:rPr lang="en-US"/>
               <a:t>Second level</a:t>
             </a:r>
           </a:p>
           <a:p>
             <a:pPr lvl="2"/>
             <a:r>
-              <a:rPr lang="en-US" smtClean="0"/>
+              <a:rPr lang="en-US"/>
               <a:t>Third level</a:t>
             </a:r>
           </a:p>
           <a:p>
             <a:pPr lvl="3"/>
             <a:r>
-              <a:rPr lang="en-US" smtClean="0"/>
+              <a:rPr lang="en-US"/>
               <a:t>Fourth level</a:t>
             </a:r>
           </a:p>
           <a:p>
             <a:pPr lvl="4"/>
             <a:r>
-              <a:rPr lang="en-US" smtClean="0"/>
+              <a:rPr lang="en-US"/>
               <a:t>Fifth level</a:t>
             </a:r>
-            <a:endParaRPr lang="en-US"/>
           </a:p>
         </p:txBody>
       </p:sp>
@@ -1489,38 +1560,37 @@
           <a:p>
             <a:pPr lvl="0"/>
             <a:r>
-              <a:rPr lang="en-US" smtClean="0"/>
+              <a:rPr lang="en-US"/>
               <a:t>Click to edit Master text styles</a:t>
             </a:r>
           </a:p>
           <a:p>
             <a:pPr lvl="1"/>
             <a:r>
-              <a:rPr lang="en-US" smtClean="0"/>
+              <a:rPr lang="en-US"/>
               <a:t>Second level</a:t>
             </a:r>
           </a:p>
           <a:p>
             <a:pPr lvl="2"/>
             <a:r>
-              <a:rPr lang="en-US" smtClean="0"/>
+              <a:rPr lang="en-US"/>
               <a:t>Third level</a:t>
             </a:r>
           </a:p>
           <a:p>
             <a:pPr lvl="3"/>
             <a:r>
-              <a:rPr lang="en-US" smtClean="0"/>
+              <a:rPr lang="en-US"/>
               <a:t>Fourth level</a:t>
             </a:r>
           </a:p>
           <a:p>
             <a:pPr lvl="4"/>
             <a:r>
-              <a:rPr lang="en-US" smtClean="0"/>
+              <a:rPr lang="en-US"/>
               <a:t>Fifth level</a:t>
             </a:r>
-            <a:endParaRPr lang="en-US"/>
           </a:p>
         </p:txBody>
       </p:sp>
@@ -1541,7 +1611,7 @@
           <a:p>
             <a:fld id="{5BCAD085-E8A6-8845-BD4E-CB4CCA059FC4}" type="datetimeFigureOut">
               <a:rPr lang="en-US" smtClean="0"/>
-              <a:t>1/27/13</a:t>
+              <a:t>7/13/26</a:t>
             </a:fld>
             <a:endParaRPr lang="en-US"/>
           </a:p>
@@ -1639,10 +1709,9 @@
           </a:lstStyle>
           <a:p>
             <a:r>
-              <a:rPr lang="en-US" smtClean="0"/>
+              <a:rPr lang="en-US"/>
               <a:t>Click to edit Master title style</a:t>
             </a:r>
-            <a:endParaRPr lang="en-US"/>
           </a:p>
         </p:txBody>
       </p:sp>
@@ -1705,7 +1774,7 @@
           <a:p>
             <a:pPr lvl="0"/>
             <a:r>
-              <a:rPr lang="en-US" smtClean="0"/>
+              <a:rPr lang="en-US"/>
               <a:t>Click to edit Master text styles</a:t>
             </a:r>
           </a:p>
@@ -1761,38 +1830,37 @@
           <a:p>
             <a:pPr lvl="0"/>
             <a:r>
-              <a:rPr lang="en-US" smtClean="0"/>
+              <a:rPr lang="en-US"/>
               <a:t>Click to edit Master text styles</a:t>
             </a:r>
           </a:p>
           <a:p>
             <a:pPr lvl="1"/>
             <a:r>
-              <a:rPr lang="en-US" smtClean="0"/>
+              <a:rPr lang="en-US"/>
               <a:t>Second level</a:t>
             </a:r>
           </a:p>
           <a:p>
             <a:pPr lvl="2"/>
             <a:r>
-              <a:rPr lang="en-US" smtClean="0"/>
+              <a:rPr lang="en-US"/>
               <a:t>Third level</a:t>
             </a:r>
           </a:p>
           <a:p>
             <a:pPr lvl="3"/>
             <a:r>
-              <a:rPr lang="en-US" smtClean="0"/>
+              <a:rPr lang="en-US"/>
               <a:t>Fourth level</a:t>
             </a:r>
           </a:p>
           <a:p>
             <a:pPr lvl="4"/>
             <a:r>
-              <a:rPr lang="en-US" smtClean="0"/>
+              <a:rPr lang="en-US"/>
               <a:t>Fifth level</a:t>
             </a:r>
-            <a:endParaRPr lang="en-US"/>
           </a:p>
         </p:txBody>
       </p:sp>
@@ -1855,7 +1923,7 @@
           <a:p>
             <a:pPr lvl="0"/>
             <a:r>
-              <a:rPr lang="en-US" smtClean="0"/>
+              <a:rPr lang="en-US"/>
               <a:t>Click to edit Master text styles</a:t>
             </a:r>
           </a:p>
@@ -1911,38 +1979,37 @@
           <a:p>
             <a:pPr lvl="0"/>
             <a:r>
-              <a:rPr lang="en-US" smtClean="0"/>
+              <a:rPr lang="en-US"/>
               <a:t>Click to edit Master text styles</a:t>
             </a:r>
           </a:p>
           <a:p>
             <a:pPr lvl="1"/>
             <a:r>
-              <a:rPr lang="en-US" smtClean="0"/>
+              <a:rPr lang="en-US"/>
               <a:t>Second level</a:t>
             </a:r>
           </a:p>
           <a:p>
             <a:pPr lvl="2"/>
             <a:r>
-              <a:rPr lang="en-US" smtClean="0"/>
+              <a:rPr lang="en-US"/>
               <a:t>Third level</a:t>
             </a:r>
           </a:p>
           <a:p>
             <a:pPr lvl="3"/>
             <a:r>
-              <a:rPr lang="en-US" smtClean="0"/>
+              <a:rPr lang="en-US"/>
               <a:t>Fourth level</a:t>
             </a:r>
           </a:p>
           <a:p>
             <a:pPr lvl="4"/>
             <a:r>
-              <a:rPr lang="en-US" smtClean="0"/>
+              <a:rPr lang="en-US"/>
               <a:t>Fifth level</a:t>
             </a:r>
-            <a:endParaRPr lang="en-US"/>
           </a:p>
         </p:txBody>
       </p:sp>
@@ -1963,7 +2030,7 @@
           <a:p>
             <a:fld id="{5BCAD085-E8A6-8845-BD4E-CB4CCA059FC4}" type="datetimeFigureOut">
               <a:rPr lang="en-US" smtClean="0"/>
-              <a:t>1/27/13</a:t>
+              <a:t>7/13/26</a:t>
             </a:fld>
             <a:endParaRPr lang="en-US"/>
           </a:p>
@@ -2057,10 +2124,9 @@
           <a:lstStyle/>
           <a:p>
             <a:r>
-              <a:rPr lang="en-US" smtClean="0"/>
+              <a:rPr lang="en-US"/>
               <a:t>Click to edit Master title style</a:t>
             </a:r>
-            <a:endParaRPr lang="en-US"/>
           </a:p>
         </p:txBody>
       </p:sp>
@@ -2081,7 +2147,7 @@
           <a:p>
             <a:fld id="{5BCAD085-E8A6-8845-BD4E-CB4CCA059FC4}" type="datetimeFigureOut">
               <a:rPr lang="en-US" smtClean="0"/>
-              <a:t>1/27/13</a:t>
+              <a:t>7/13/26</a:t>
             </a:fld>
             <a:endParaRPr lang="en-US"/>
           </a:p>
@@ -2176,7 +2242,7 @@
           <a:p>
             <a:fld id="{5BCAD085-E8A6-8845-BD4E-CB4CCA059FC4}" type="datetimeFigureOut">
               <a:rPr lang="en-US" smtClean="0"/>
-              <a:t>1/27/13</a:t>
+              <a:t>7/13/26</a:t>
             </a:fld>
             <a:endParaRPr lang="en-US"/>
           </a:p>
@@ -2279,10 +2345,9 @@
           </a:lstStyle>
           <a:p>
             <a:r>
-              <a:rPr lang="en-US" smtClean="0"/>
+              <a:rPr lang="en-US"/>
               <a:t>Click to edit Master title style</a:t>
             </a:r>
-            <a:endParaRPr lang="en-US"/>
           </a:p>
         </p:txBody>
       </p:sp>
@@ -2336,38 +2401,37 @@
           <a:p>
             <a:pPr lvl="0"/>
             <a:r>
-              <a:rPr lang="en-US" smtClean="0"/>
+              <a:rPr lang="en-US"/>
               <a:t>Click to edit Master text styles</a:t>
             </a:r>
           </a:p>
           <a:p>
             <a:pPr lvl="1"/>
             <a:r>
-              <a:rPr lang="en-US" smtClean="0"/>
+              <a:rPr lang="en-US"/>
               <a:t>Second level</a:t>
             </a:r>
           </a:p>
           <a:p>
             <a:pPr lvl="2"/>
             <a:r>
-              <a:rPr lang="en-US" smtClean="0"/>
+              <a:rPr lang="en-US"/>
               <a:t>Third level</a:t>
             </a:r>
           </a:p>
           <a:p>
             <a:pPr lvl="3"/>
             <a:r>
-              <a:rPr lang="en-US" smtClean="0"/>
+              <a:rPr lang="en-US"/>
               <a:t>Fourth level</a:t>
             </a:r>
           </a:p>
           <a:p>
             <a:pPr lvl="4"/>
             <a:r>
-              <a:rPr lang="en-US" smtClean="0"/>
+              <a:rPr lang="en-US"/>
               <a:t>Fifth level</a:t>
             </a:r>
-            <a:endParaRPr lang="en-US"/>
           </a:p>
         </p:txBody>
       </p:sp>
@@ -2430,7 +2494,7 @@
           <a:p>
             <a:pPr lvl="0"/>
             <a:r>
-              <a:rPr lang="en-US" smtClean="0"/>
+              <a:rPr lang="en-US"/>
               <a:t>Click to edit Master text styles</a:t>
             </a:r>
           </a:p>
@@ -2453,7 +2517,7 @@
           <a:p>
             <a:fld id="{5BCAD085-E8A6-8845-BD4E-CB4CCA059FC4}" type="datetimeFigureOut">
               <a:rPr lang="en-US" smtClean="0"/>
-              <a:t>1/27/13</a:t>
+              <a:t>7/13/26</a:t>
             </a:fld>
             <a:endParaRPr lang="en-US"/>
           </a:p>
@@ -2556,10 +2620,9 @@
           </a:lstStyle>
           <a:p>
             <a:r>
-              <a:rPr lang="en-US" smtClean="0"/>
+              <a:rPr lang="en-US"/>
               <a:t>Click to edit Master title style</a:t>
             </a:r>
-            <a:endParaRPr lang="en-US"/>
           </a:p>
         </p:txBody>
       </p:sp>
@@ -2683,7 +2746,7 @@
           <a:p>
             <a:pPr lvl="0"/>
             <a:r>
-              <a:rPr lang="en-US" smtClean="0"/>
+              <a:rPr lang="en-US"/>
               <a:t>Click to edit Master text styles</a:t>
             </a:r>
           </a:p>
@@ -2706,7 +2769,7 @@
           <a:p>
             <a:fld id="{5BCAD085-E8A6-8845-BD4E-CB4CCA059FC4}" type="datetimeFigureOut">
               <a:rPr lang="en-US" smtClean="0"/>
-              <a:t>1/27/13</a:t>
+              <a:t>7/13/26</a:t>
             </a:fld>
             <a:endParaRPr lang="en-US"/>
           </a:p>
@@ -2815,10 +2878,9 @@
           <a:lstStyle/>
           <a:p>
             <a:r>
-              <a:rPr lang="en-US" smtClean="0"/>
+              <a:rPr lang="en-US"/>
               <a:t>Click to edit Master title style</a:t>
             </a:r>
-            <a:endParaRPr lang="en-US"/>
           </a:p>
         </p:txBody>
       </p:sp>
@@ -2849,38 +2911,37 @@
           <a:p>
             <a:pPr lvl="0"/>
             <a:r>
-              <a:rPr lang="en-US" smtClean="0"/>
+              <a:rPr lang="en-US"/>
               <a:t>Click to edit Master text styles</a:t>
             </a:r>
           </a:p>
           <a:p>
             <a:pPr lvl="1"/>
             <a:r>
-              <a:rPr lang="en-US" smtClean="0"/>
+              <a:rPr lang="en-US"/>
               <a:t>Second level</a:t>
             </a:r>
           </a:p>
           <a:p>
             <a:pPr lvl="2"/>
             <a:r>
-              <a:rPr lang="en-US" smtClean="0"/>
+              <a:rPr lang="en-US"/>
               <a:t>Third level</a:t>
             </a:r>
           </a:p>
           <a:p>
             <a:pPr lvl="3"/>
             <a:r>
-              <a:rPr lang="en-US" smtClean="0"/>
+              <a:rPr lang="en-US"/>
               <a:t>Fourth level</a:t>
             </a:r>
           </a:p>
           <a:p>
             <a:pPr lvl="4"/>
             <a:r>
-              <a:rPr lang="en-US" smtClean="0"/>
+              <a:rPr lang="en-US"/>
               <a:t>Fifth level</a:t>
             </a:r>
-            <a:endParaRPr lang="en-US"/>
           </a:p>
         </p:txBody>
       </p:sp>
@@ -2919,7 +2980,7 @@
           <a:p>
             <a:fld id="{5BCAD085-E8A6-8845-BD4E-CB4CCA059FC4}" type="datetimeFigureOut">
               <a:rPr lang="en-US" smtClean="0"/>
-              <a:t>1/27/13</a:t>
+              <a:t>7/13/26</a:t>
             </a:fld>
             <a:endParaRPr lang="en-US"/>
           </a:p>
@@ -3278,7 +3339,7 @@
 </file>
 
 <file path=ppt/slides/slide1.xml><?xml version="1.0" encoding="utf-8"?>
-<p:sld xmlns:a="http://schemas.openxmlformats.org/drawingml/2006/main" xmlns:p="http://schemas.openxmlformats.org/presentationml/2006/main" xmlns:r="http://schemas.openxmlformats.org/officeDocument/2006/relationships">
+<p:sld xmlns:a="http://schemas.openxmlformats.org/drawingml/2006/main" xmlns:r="http://schemas.openxmlformats.org/officeDocument/2006/relationships" xmlns:p="http://schemas.openxmlformats.org/presentationml/2006/main">
   <p:cSld>
     <p:bg>
       <p:bgPr>
@@ -3294,7 +3355,14 @@
         <p:cNvGrpSpPr/>
         <p:nvPr/>
       </p:nvGrpSpPr>
-      <p:grpSpPr/>
+      <p:grpSpPr>
+        <a:xfrm>
+          <a:off x="0" y="0"/>
+          <a:ext cx="0" cy="0"/>
+          <a:chOff x="0" y="0"/>
+          <a:chExt cx="0" cy="0"/>
+        </a:xfrm>
+      </p:grpSpPr>
       <p:sp>
         <p:nvSpPr>
           <p:cNvPr id="2" name="TextBox 1"/>
@@ -3312,7 +3380,7 @@
           <a:noFill/>
         </p:spPr>
         <p:txBody>
-          <a:bodyPr wrap="square" anchor="t" lIns="0" rIns="0" tIns="0" bIns="0">
+          <a:bodyPr wrap="square" lIns="0" tIns="0" rIns="0" bIns="0" anchor="t">
             <a:spAutoFit/>
           </a:bodyPr>
           <a:lstStyle/>
@@ -3323,9 +3391,9 @@
                 <a:solidFill>
                   <a:srgbClr val="FFFFFF"/>
                 </a:solidFill>
-                <a:latin typeface="Unbounded"/>
-              </a:rPr>
-              <a:t>ПЛАНОМЕТРИКА</a:t>
+                <a:latin typeface="Unbounded Medium"/>
+              </a:rPr>
+              <a:t>Планометрика</a:t>
             </a:r>
           </a:p>
         </p:txBody>
@@ -3371,6 +3439,7 @@
           <a:lstStyle/>
           <a:p>
             <a:pPr algn="ctr"/>
+            <a:endParaRPr/>
           </a:p>
         </p:txBody>
       </p:sp>
@@ -3391,7 +3460,7 @@
           <a:noFill/>
         </p:spPr>
         <p:txBody>
-          <a:bodyPr wrap="square" anchor="t" lIns="0" rIns="0" tIns="0" bIns="0">
+          <a:bodyPr wrap="square" lIns="0" tIns="0" rIns="0" bIns="0" anchor="t">
             <a:spAutoFit/>
           </a:bodyPr>
           <a:lstStyle/>
@@ -3426,7 +3495,7 @@
           <a:noFill/>
         </p:spPr>
         <p:txBody>
-          <a:bodyPr wrap="square" anchor="t" lIns="0" rIns="0" tIns="0" bIns="0">
+          <a:bodyPr wrap="square" lIns="0" tIns="0" rIns="0" bIns="0" anchor="t">
             <a:spAutoFit/>
           </a:bodyPr>
           <a:lstStyle/>
@@ -3461,7 +3530,7 @@
           <a:noFill/>
         </p:spPr>
         <p:txBody>
-          <a:bodyPr wrap="square" anchor="t" lIns="0" rIns="0" tIns="0" bIns="0">
+          <a:bodyPr wrap="square" lIns="0" tIns="0" rIns="0" bIns="0" anchor="t">
             <a:spAutoFit/>
           </a:bodyPr>
           <a:lstStyle/>
@@ -3472,98 +3541,10 @@
                 <a:solidFill>
                   <a:srgbClr val="92CF93"/>
                 </a:solidFill>
-                <a:latin typeface="JetBrains Mono"/>
+                <a:latin typeface="JetBrains Mono Medium"/>
               </a:rPr>
               <a:t>2026 · planometrica.pro</a:t>
             </a:r>
-          </a:p>
-        </p:txBody>
-      </p:sp>
-      <p:sp>
-        <p:nvSpPr>
-          <p:cNvPr id="7" name="Rectangle 6"/>
-          <p:cNvSpPr/>
-          <p:nvPr/>
-        </p:nvSpPr>
-        <p:spPr>
-          <a:xfrm>
-            <a:off x="11091672" y="0"/>
-            <a:ext cx="1097280" cy="201168"/>
-          </a:xfrm>
-          <a:prstGeom prst="rect">
-            <a:avLst/>
-          </a:prstGeom>
-          <a:solidFill>
-            <a:srgbClr val="F59E0B"/>
-          </a:solidFill>
-          <a:ln>
-            <a:noFill/>
-          </a:ln>
-          <a:effectLst/>
-        </p:spPr>
-        <p:style>
-          <a:lnRef idx="1">
-            <a:schemeClr val="accent1"/>
-          </a:lnRef>
-          <a:fillRef idx="3">
-            <a:schemeClr val="accent1"/>
-          </a:fillRef>
-          <a:effectRef idx="2">
-            <a:schemeClr val="accent1"/>
-          </a:effectRef>
-          <a:fontRef idx="minor">
-            <a:schemeClr val="lt1"/>
-          </a:fontRef>
-        </p:style>
-        <p:txBody>
-          <a:bodyPr rtlCol="0" anchor="ctr"/>
-          <a:lstStyle/>
-          <a:p>
-            <a:pPr algn="ctr"/>
-          </a:p>
-        </p:txBody>
-      </p:sp>
-      <p:sp>
-        <p:nvSpPr>
-          <p:cNvPr id="8" name="Rectangle 7"/>
-          <p:cNvSpPr/>
-          <p:nvPr/>
-        </p:nvSpPr>
-        <p:spPr>
-          <a:xfrm>
-            <a:off x="11640312" y="201168"/>
-            <a:ext cx="548640" cy="201168"/>
-          </a:xfrm>
-          <a:prstGeom prst="rect">
-            <a:avLst/>
-          </a:prstGeom>
-          <a:solidFill>
-            <a:srgbClr val="92CF93"/>
-          </a:solidFill>
-          <a:ln>
-            <a:noFill/>
-          </a:ln>
-          <a:effectLst/>
-        </p:spPr>
-        <p:style>
-          <a:lnRef idx="1">
-            <a:schemeClr val="accent1"/>
-          </a:lnRef>
-          <a:fillRef idx="3">
-            <a:schemeClr val="accent1"/>
-          </a:fillRef>
-          <a:effectRef idx="2">
-            <a:schemeClr val="accent1"/>
-          </a:effectRef>
-          <a:fontRef idx="minor">
-            <a:schemeClr val="lt1"/>
-          </a:fontRef>
-        </p:style>
-        <p:txBody>
-          <a:bodyPr rtlCol="0" anchor="ctr"/>
-          <a:lstStyle/>
-          <a:p>
-            <a:pPr algn="ctr"/>
           </a:p>
         </p:txBody>
       </p:sp>
@@ -3576,7 +3557,7 @@
 </file>
 
 <file path=ppt/slides/slide2.xml><?xml version="1.0" encoding="utf-8"?>
-<p:sld xmlns:a="http://schemas.openxmlformats.org/drawingml/2006/main" xmlns:p="http://schemas.openxmlformats.org/presentationml/2006/main" xmlns:r="http://schemas.openxmlformats.org/officeDocument/2006/relationships">
+<p:sld xmlns:a="http://schemas.openxmlformats.org/drawingml/2006/main" xmlns:r="http://schemas.openxmlformats.org/officeDocument/2006/relationships" xmlns:p="http://schemas.openxmlformats.org/presentationml/2006/main">
   <p:cSld>
     <p:bg>
       <p:bgPr>
@@ -3592,7 +3573,14 @@
         <p:cNvGrpSpPr/>
         <p:nvPr/>
       </p:nvGrpSpPr>
-      <p:grpSpPr/>
+      <p:grpSpPr>
+        <a:xfrm>
+          <a:off x="0" y="0"/>
+          <a:ext cx="0" cy="0"/>
+          <a:chOff x="0" y="0"/>
+          <a:chExt cx="0" cy="0"/>
+        </a:xfrm>
+      </p:grpSpPr>
       <p:sp>
         <p:nvSpPr>
           <p:cNvPr id="2" name="TextBox 1"/>
@@ -3610,7 +3598,7 @@
           <a:noFill/>
         </p:spPr>
         <p:txBody>
-          <a:bodyPr wrap="square" anchor="t" lIns="0" rIns="0" tIns="0" bIns="0">
+          <a:bodyPr wrap="square" lIns="0" tIns="0" rIns="0" bIns="0" anchor="t">
             <a:spAutoFit/>
           </a:bodyPr>
           <a:lstStyle/>
@@ -3669,6 +3657,7 @@
           <a:lstStyle/>
           <a:p>
             <a:pPr algn="ctr"/>
+            <a:endParaRPr/>
           </a:p>
         </p:txBody>
       </p:sp>
@@ -3689,7 +3678,7 @@
           <a:noFill/>
         </p:spPr>
         <p:txBody>
-          <a:bodyPr wrap="square" anchor="t" lIns="0" rIns="0" tIns="0" bIns="0">
+          <a:bodyPr wrap="square" lIns="0" tIns="0" rIns="0" bIns="0" anchor="t">
             <a:spAutoFit/>
           </a:bodyPr>
           <a:lstStyle/>
@@ -3724,7 +3713,7 @@
           <a:noFill/>
         </p:spPr>
         <p:txBody>
-          <a:bodyPr wrap="square" anchor="t" lIns="0" rIns="0" tIns="0" bIns="0">
+          <a:bodyPr wrap="square" lIns="0" tIns="0" rIns="0" bIns="0" anchor="t">
             <a:spAutoFit/>
           </a:bodyPr>
           <a:lstStyle/>
@@ -3735,7 +3724,7 @@
                 <a:solidFill>
                   <a:srgbClr val="F0F9FF"/>
                 </a:solidFill>
-                <a:latin typeface="JetBrains Mono"/>
+                <a:latin typeface="JetBrains Mono Medium"/>
               </a:rPr>
               <a:t>Пояснение к разделу — основной текст в JetBrains Mono</a:t>
             </a:r>
@@ -3751,7 +3740,7 @@
 </file>
 
 <file path=ppt/slides/slide3.xml><?xml version="1.0" encoding="utf-8"?>
-<p:sld xmlns:a="http://schemas.openxmlformats.org/drawingml/2006/main" xmlns:p="http://schemas.openxmlformats.org/presentationml/2006/main" xmlns:r="http://schemas.openxmlformats.org/officeDocument/2006/relationships">
+<p:sld xmlns:a="http://schemas.openxmlformats.org/drawingml/2006/main" xmlns:r="http://schemas.openxmlformats.org/officeDocument/2006/relationships" xmlns:p="http://schemas.openxmlformats.org/presentationml/2006/main">
   <p:cSld>
     <p:bg>
       <p:bgPr>
@@ -3767,7 +3756,14 @@
         <p:cNvGrpSpPr/>
         <p:nvPr/>
       </p:nvGrpSpPr>
-      <p:grpSpPr/>
+      <p:grpSpPr>
+        <a:xfrm>
+          <a:off x="0" y="0"/>
+          <a:ext cx="0" cy="0"/>
+          <a:chOff x="0" y="0"/>
+          <a:chExt cx="0" cy="0"/>
+        </a:xfrm>
+      </p:grpSpPr>
       <p:sp>
         <p:nvSpPr>
           <p:cNvPr id="2" name="TextBox 1"/>
@@ -3785,7 +3781,7 @@
           <a:noFill/>
         </p:spPr>
         <p:txBody>
-          <a:bodyPr wrap="square" anchor="t" lIns="0" rIns="0" tIns="0" bIns="0">
+          <a:bodyPr wrap="square" lIns="0" tIns="0" rIns="0" bIns="0" anchor="t">
             <a:spAutoFit/>
           </a:bodyPr>
           <a:lstStyle/>
@@ -3844,6 +3840,7 @@
           <a:lstStyle/>
           <a:p>
             <a:pPr algn="ctr"/>
+            <a:endParaRPr/>
           </a:p>
         </p:txBody>
       </p:sp>
@@ -3864,7 +3861,7 @@
           <a:noFill/>
         </p:spPr>
         <p:txBody>
-          <a:bodyPr wrap="square" anchor="t" lIns="0" rIns="0" tIns="0" bIns="0">
+          <a:bodyPr wrap="square" lIns="0" tIns="0" rIns="0" bIns="0" anchor="t">
             <a:spAutoFit/>
           </a:bodyPr>
           <a:lstStyle/>
@@ -3882,7 +3879,7 @@
                 <a:solidFill>
                   <a:srgbClr val="0F172A"/>
                 </a:solidFill>
-                <a:latin typeface="JetBrains Mono"/>
+                <a:latin typeface="JetBrains Mono Medium"/>
               </a:rPr>
               <a:t>—  Основной текст набирается JetBrains Mono — канон дизайн-системы</a:t>
             </a:r>
@@ -3901,7 +3898,7 @@
                 <a:solidFill>
                   <a:srgbClr val="0F172A"/>
                 </a:solidFill>
-                <a:latin typeface="JetBrains Mono"/>
+                <a:latin typeface="JetBrains Mono Medium"/>
               </a:rPr>
               <a:t>—  Заголовки и подзаголовки — Manrope</a:t>
             </a:r>
@@ -3920,7 +3917,7 @@
                 <a:solidFill>
                   <a:srgbClr val="0F172A"/>
                 </a:solidFill>
-                <a:latin typeface="JetBrains Mono"/>
+                <a:latin typeface="JetBrains Mono Medium"/>
               </a:rPr>
               <a:t>—  Unbounded используется только для нейминга «Планометрика»</a:t>
             </a:r>
@@ -3939,7 +3936,7 @@
                 <a:solidFill>
                   <a:srgbClr val="0F172A"/>
                 </a:solidFill>
-                <a:latin typeface="JetBrains Mono"/>
+                <a:latin typeface="JetBrains Mono Medium"/>
               </a:rPr>
               <a:t>—  Цвета — строго из палитры @planometrica/ui</a:t>
             </a:r>
@@ -3963,7 +3960,7 @@
           <a:noFill/>
         </p:spPr>
         <p:txBody>
-          <a:bodyPr wrap="square" anchor="t" lIns="0" rIns="0" tIns="0" bIns="0">
+          <a:bodyPr wrap="square" lIns="0" tIns="0" rIns="0" bIns="0" anchor="t">
             <a:spAutoFit/>
           </a:bodyPr>
           <a:lstStyle/>
@@ -3974,7 +3971,7 @@
                 <a:solidFill>
                   <a:srgbClr val="64748B"/>
                 </a:solidFill>
-                <a:latin typeface="JetBrains Mono"/>
+                <a:latin typeface="JetBrains Mono Medium"/>
               </a:rPr>
               <a:t>Примечание: подписи и сноски — JetBrains Mono, muted #64748B</a:t>
             </a:r>
@@ -3998,7 +3995,7 @@
           <a:noFill/>
         </p:spPr>
         <p:txBody>
-          <a:bodyPr wrap="square" anchor="t" lIns="0" rIns="0" tIns="0" bIns="0">
+          <a:bodyPr wrap="square" lIns="0" tIns="0" rIns="0" bIns="0" anchor="t">
             <a:spAutoFit/>
           </a:bodyPr>
           <a:lstStyle/>
@@ -4009,9 +4006,9 @@
                 <a:solidFill>
                   <a:srgbClr val="0A4C76"/>
                 </a:solidFill>
-                <a:latin typeface="Unbounded"/>
-              </a:rPr>
-              <a:t>ПЛАНОМЕТРИКА</a:t>
+                <a:latin typeface="Unbounded Medium"/>
+              </a:rPr>
+              <a:t>Планометрика</a:t>
             </a:r>
           </a:p>
         </p:txBody>
@@ -4033,7 +4030,7 @@
           <a:noFill/>
         </p:spPr>
         <p:txBody>
-          <a:bodyPr wrap="square" anchor="t" lIns="0" rIns="0" tIns="0" bIns="0">
+          <a:bodyPr wrap="square" lIns="0" tIns="0" rIns="0" bIns="0" anchor="t">
             <a:spAutoFit/>
           </a:bodyPr>
           <a:lstStyle/>
@@ -4044,7 +4041,7 @@
                 <a:solidFill>
                   <a:srgbClr val="64748B"/>
                 </a:solidFill>
-                <a:latin typeface="JetBrains Mono"/>
+                <a:latin typeface="JetBrains Mono Medium"/>
               </a:rPr>
               <a:t>03</a:t>
             </a:r>
@@ -4060,7 +4057,7 @@
 </file>
 
 <file path=ppt/slides/slide4.xml><?xml version="1.0" encoding="utf-8"?>
-<p:sld xmlns:a="http://schemas.openxmlformats.org/drawingml/2006/main" xmlns:p="http://schemas.openxmlformats.org/presentationml/2006/main" xmlns:r="http://schemas.openxmlformats.org/officeDocument/2006/relationships">
+<p:sld xmlns:a="http://schemas.openxmlformats.org/drawingml/2006/main" xmlns:r="http://schemas.openxmlformats.org/officeDocument/2006/relationships" xmlns:p="http://schemas.openxmlformats.org/presentationml/2006/main">
   <p:cSld>
     <p:bg>
       <p:bgPr>
@@ -4076,7 +4073,14 @@
         <p:cNvGrpSpPr/>
         <p:nvPr/>
       </p:nvGrpSpPr>
-      <p:grpSpPr/>
+      <p:grpSpPr>
+        <a:xfrm>
+          <a:off x="0" y="0"/>
+          <a:ext cx="0" cy="0"/>
+          <a:chOff x="0" y="0"/>
+          <a:chExt cx="0" cy="0"/>
+        </a:xfrm>
+      </p:grpSpPr>
       <p:sp>
         <p:nvSpPr>
           <p:cNvPr id="2" name="TextBox 1"/>
@@ -4094,7 +4098,7 @@
           <a:noFill/>
         </p:spPr>
         <p:txBody>
-          <a:bodyPr wrap="square" anchor="t" lIns="0" rIns="0" tIns="0" bIns="0">
+          <a:bodyPr wrap="square" lIns="0" tIns="0" rIns="0" bIns="0" anchor="t">
             <a:spAutoFit/>
           </a:bodyPr>
           <a:lstStyle/>
@@ -4153,6 +4157,7 @@
           <a:lstStyle/>
           <a:p>
             <a:pPr algn="ctr"/>
+            <a:endParaRPr/>
           </a:p>
         </p:txBody>
       </p:sp>
@@ -4199,6 +4204,7 @@
           <a:lstStyle/>
           <a:p>
             <a:pPr algn="ctr"/>
+            <a:endParaRPr/>
           </a:p>
         </p:txBody>
       </p:sp>
@@ -4243,6 +4249,7 @@
           <a:lstStyle/>
           <a:p>
             <a:pPr algn="ctr"/>
+            <a:endParaRPr/>
           </a:p>
         </p:txBody>
       </p:sp>
@@ -4263,7 +4270,7 @@
           <a:noFill/>
         </p:spPr>
         <p:txBody>
-          <a:bodyPr wrap="square" anchor="t" lIns="0" rIns="0" tIns="0" bIns="0">
+          <a:bodyPr wrap="square" lIns="0" tIns="0" rIns="0" bIns="0" anchor="t">
             <a:spAutoFit/>
           </a:bodyPr>
           <a:lstStyle/>
@@ -4298,7 +4305,7 @@
           <a:noFill/>
         </p:spPr>
         <p:txBody>
-          <a:bodyPr wrap="square" anchor="t" lIns="0" rIns="0" tIns="0" bIns="0">
+          <a:bodyPr wrap="square" lIns="0" tIns="0" rIns="0" bIns="0" anchor="t">
             <a:spAutoFit/>
           </a:bodyPr>
           <a:lstStyle/>
@@ -4313,7 +4320,7 @@
                 <a:solidFill>
                   <a:srgbClr val="0F172A"/>
                 </a:solidFill>
-                <a:latin typeface="JetBrains Mono"/>
+                <a:latin typeface="JetBrains Mono Medium"/>
               </a:rPr>
               <a:t>Текст карточки — JetBrains Mono 13pt. Фон карточки — semantic secondary #F0F9FF, рамка — border #E2E8F0.</a:t>
             </a:r>
@@ -4363,6 +4370,7 @@
           <a:lstStyle/>
           <a:p>
             <a:pPr algn="ctr"/>
+            <a:endParaRPr/>
           </a:p>
         </p:txBody>
       </p:sp>
@@ -4407,6 +4415,7 @@
           <a:lstStyle/>
           <a:p>
             <a:pPr algn="ctr"/>
+            <a:endParaRPr/>
           </a:p>
         </p:txBody>
       </p:sp>
@@ -4427,7 +4436,7 @@
           <a:noFill/>
         </p:spPr>
         <p:txBody>
-          <a:bodyPr wrap="square" anchor="t" lIns="0" rIns="0" tIns="0" bIns="0">
+          <a:bodyPr wrap="square" lIns="0" tIns="0" rIns="0" bIns="0" anchor="t">
             <a:spAutoFit/>
           </a:bodyPr>
           <a:lstStyle/>
@@ -4462,7 +4471,7 @@
           <a:noFill/>
         </p:spPr>
         <p:txBody>
-          <a:bodyPr wrap="square" anchor="t" lIns="0" rIns="0" tIns="0" bIns="0">
+          <a:bodyPr wrap="square" lIns="0" tIns="0" rIns="0" bIns="0" anchor="t">
             <a:spAutoFit/>
           </a:bodyPr>
           <a:lstStyle/>
@@ -4477,7 +4486,7 @@
                 <a:solidFill>
                   <a:srgbClr val="0F172A"/>
                 </a:solidFill>
-                <a:latin typeface="JetBrains Mono"/>
+                <a:latin typeface="JetBrains Mono Medium"/>
               </a:rPr>
               <a:t>Текст карточки — JetBrains Mono 13pt. Фон карточки — semantic secondary #F0F9FF, рамка — border #E2E8F0.</a:t>
             </a:r>
@@ -4501,7 +4510,7 @@
           <a:noFill/>
         </p:spPr>
         <p:txBody>
-          <a:bodyPr wrap="square" anchor="t" lIns="0" rIns="0" tIns="0" bIns="0">
+          <a:bodyPr wrap="square" lIns="0" tIns="0" rIns="0" bIns="0" anchor="t">
             <a:spAutoFit/>
           </a:bodyPr>
           <a:lstStyle/>
@@ -4512,9 +4521,9 @@
                 <a:solidFill>
                   <a:srgbClr val="0A4C76"/>
                 </a:solidFill>
-                <a:latin typeface="Unbounded"/>
-              </a:rPr>
-              <a:t>ПЛАНОМЕТРИКА</a:t>
+                <a:latin typeface="Unbounded Medium"/>
+              </a:rPr>
+              <a:t>Планометрика</a:t>
             </a:r>
           </a:p>
         </p:txBody>
@@ -4536,7 +4545,7 @@
           <a:noFill/>
         </p:spPr>
         <p:txBody>
-          <a:bodyPr wrap="square" anchor="t" lIns="0" rIns="0" tIns="0" bIns="0">
+          <a:bodyPr wrap="square" lIns="0" tIns="0" rIns="0" bIns="0" anchor="t">
             <a:spAutoFit/>
           </a:bodyPr>
           <a:lstStyle/>
@@ -4547,7 +4556,7 @@
                 <a:solidFill>
                   <a:srgbClr val="64748B"/>
                 </a:solidFill>
-                <a:latin typeface="JetBrains Mono"/>
+                <a:latin typeface="JetBrains Mono Medium"/>
               </a:rPr>
               <a:t>04</a:t>
             </a:r>
@@ -4563,7 +4572,7 @@
 </file>
 
 <file path=ppt/slides/slide5.xml><?xml version="1.0" encoding="utf-8"?>
-<p:sld xmlns:a="http://schemas.openxmlformats.org/drawingml/2006/main" xmlns:p="http://schemas.openxmlformats.org/presentationml/2006/main" xmlns:r="http://schemas.openxmlformats.org/officeDocument/2006/relationships">
+<p:sld xmlns:a="http://schemas.openxmlformats.org/drawingml/2006/main" xmlns:r="http://schemas.openxmlformats.org/officeDocument/2006/relationships" xmlns:p="http://schemas.openxmlformats.org/presentationml/2006/main">
   <p:cSld>
     <p:bg>
       <p:bgPr>
@@ -4579,7 +4588,14 @@
         <p:cNvGrpSpPr/>
         <p:nvPr/>
       </p:nvGrpSpPr>
-      <p:grpSpPr/>
+      <p:grpSpPr>
+        <a:xfrm>
+          <a:off x="0" y="0"/>
+          <a:ext cx="0" cy="0"/>
+          <a:chOff x="0" y="0"/>
+          <a:chExt cx="0" cy="0"/>
+        </a:xfrm>
+      </p:grpSpPr>
       <p:sp>
         <p:nvSpPr>
           <p:cNvPr id="2" name="TextBox 1"/>
@@ -4597,7 +4613,7 @@
           <a:noFill/>
         </p:spPr>
         <p:txBody>
-          <a:bodyPr wrap="square" anchor="t" lIns="0" rIns="0" tIns="0" bIns="0">
+          <a:bodyPr wrap="square" lIns="0" tIns="0" rIns="0" bIns="0" anchor="t">
             <a:spAutoFit/>
           </a:bodyPr>
           <a:lstStyle/>
@@ -4656,6 +4672,7 @@
           <a:lstStyle/>
           <a:p>
             <a:pPr algn="ctr"/>
+            <a:endParaRPr/>
           </a:p>
         </p:txBody>
       </p:sp>
@@ -4700,6 +4717,7 @@
           <a:lstStyle/>
           <a:p>
             <a:pPr algn="ctr"/>
+            <a:endParaRPr/>
           </a:p>
         </p:txBody>
       </p:sp>
@@ -4720,7 +4738,7 @@
           <a:noFill/>
         </p:spPr>
         <p:txBody>
-          <a:bodyPr wrap="square" anchor="t" lIns="0" rIns="0" tIns="0" bIns="0">
+          <a:bodyPr wrap="square" lIns="0" tIns="0" rIns="0" bIns="0" anchor="t">
             <a:spAutoFit/>
           </a:bodyPr>
           <a:lstStyle/>
@@ -4743,7 +4761,7 @@
                 <a:solidFill>
                   <a:srgbClr val="64748B"/>
                 </a:solidFill>
-                <a:latin typeface="JetBrains Mono"/>
+                <a:latin typeface="JetBrains Mono Medium"/>
               </a:rPr>
               <a:t>#0A4C76</a:t>
             </a:r>
@@ -4755,7 +4773,7 @@
                 <a:solidFill>
                   <a:srgbClr val="64748B"/>
                 </a:solidFill>
-                <a:latin typeface="JetBrains Mono"/>
+                <a:latin typeface="JetBrains Mono Medium"/>
               </a:rPr>
               <a:t>brand.primary</a:t>
             </a:r>
@@ -4803,6 +4821,7 @@
           <a:lstStyle/>
           <a:p>
             <a:pPr algn="ctr"/>
+            <a:endParaRPr/>
           </a:p>
         </p:txBody>
       </p:sp>
@@ -4823,7 +4842,7 @@
           <a:noFill/>
         </p:spPr>
         <p:txBody>
-          <a:bodyPr wrap="square" anchor="t" lIns="0" rIns="0" tIns="0" bIns="0">
+          <a:bodyPr wrap="square" lIns="0" tIns="0" rIns="0" bIns="0" anchor="t">
             <a:spAutoFit/>
           </a:bodyPr>
           <a:lstStyle/>
@@ -4846,7 +4865,7 @@
                 <a:solidFill>
                   <a:srgbClr val="64748B"/>
                 </a:solidFill>
-                <a:latin typeface="JetBrains Mono"/>
+                <a:latin typeface="JetBrains Mono Medium"/>
               </a:rPr>
               <a:t>#1A7BB3</a:t>
             </a:r>
@@ -4858,7 +4877,7 @@
                 <a:solidFill>
                   <a:srgbClr val="64748B"/>
                 </a:solidFill>
-                <a:latin typeface="JetBrains Mono"/>
+                <a:latin typeface="JetBrains Mono Medium"/>
               </a:rPr>
               <a:t>brand.secondary</a:t>
             </a:r>
@@ -4906,6 +4925,7 @@
           <a:lstStyle/>
           <a:p>
             <a:pPr algn="ctr"/>
+            <a:endParaRPr/>
           </a:p>
         </p:txBody>
       </p:sp>
@@ -4926,7 +4946,7 @@
           <a:noFill/>
         </p:spPr>
         <p:txBody>
-          <a:bodyPr wrap="square" anchor="t" lIns="0" rIns="0" tIns="0" bIns="0">
+          <a:bodyPr wrap="square" lIns="0" tIns="0" rIns="0" bIns="0" anchor="t">
             <a:spAutoFit/>
           </a:bodyPr>
           <a:lstStyle/>
@@ -4949,7 +4969,7 @@
                 <a:solidFill>
                   <a:srgbClr val="64748B"/>
                 </a:solidFill>
-                <a:latin typeface="JetBrains Mono"/>
+                <a:latin typeface="JetBrains Mono Medium"/>
               </a:rPr>
               <a:t>#92CF93</a:t>
             </a:r>
@@ -4961,7 +4981,7 @@
                 <a:solidFill>
                   <a:srgbClr val="64748B"/>
                 </a:solidFill>
-                <a:latin typeface="JetBrains Mono"/>
+                <a:latin typeface="JetBrains Mono Medium"/>
               </a:rPr>
               <a:t>brand.green</a:t>
             </a:r>
@@ -5009,6 +5029,7 @@
           <a:lstStyle/>
           <a:p>
             <a:pPr algn="ctr"/>
+            <a:endParaRPr/>
           </a:p>
         </p:txBody>
       </p:sp>
@@ -5029,7 +5050,7 @@
           <a:noFill/>
         </p:spPr>
         <p:txBody>
-          <a:bodyPr wrap="square" anchor="t" lIns="0" rIns="0" tIns="0" bIns="0">
+          <a:bodyPr wrap="square" lIns="0" tIns="0" rIns="0" bIns="0" anchor="t">
             <a:spAutoFit/>
           </a:bodyPr>
           <a:lstStyle/>
@@ -5052,7 +5073,7 @@
                 <a:solidFill>
                   <a:srgbClr val="64748B"/>
                 </a:solidFill>
-                <a:latin typeface="JetBrains Mono"/>
+                <a:latin typeface="JetBrains Mono Medium"/>
               </a:rPr>
               <a:t>#F59E0B</a:t>
             </a:r>
@@ -5064,7 +5085,7 @@
                 <a:solidFill>
                   <a:srgbClr val="64748B"/>
                 </a:solidFill>
-                <a:latin typeface="JetBrains Mono"/>
+                <a:latin typeface="JetBrains Mono Medium"/>
               </a:rPr>
               <a:t>brand.orange</a:t>
             </a:r>
@@ -5088,7 +5109,7 @@
           <a:noFill/>
         </p:spPr>
         <p:txBody>
-          <a:bodyPr wrap="square" anchor="t" lIns="0" rIns="0" tIns="0" bIns="0">
+          <a:bodyPr wrap="square" lIns="0" tIns="0" rIns="0" bIns="0" anchor="t">
             <a:spAutoFit/>
           </a:bodyPr>
           <a:lstStyle/>
@@ -5147,6 +5168,7 @@
           <a:lstStyle/>
           <a:p>
             <a:pPr algn="ctr"/>
+            <a:endParaRPr/>
           </a:p>
         </p:txBody>
       </p:sp>
@@ -5167,7 +5189,7 @@
           <a:noFill/>
         </p:spPr>
         <p:txBody>
-          <a:bodyPr wrap="square" anchor="t" lIns="0" rIns="0" tIns="0" bIns="0">
+          <a:bodyPr wrap="square" lIns="0" tIns="0" rIns="0" bIns="0" anchor="t">
             <a:spAutoFit/>
           </a:bodyPr>
           <a:lstStyle/>
@@ -5190,7 +5212,7 @@
                 <a:solidFill>
                   <a:srgbClr val="64748B"/>
                 </a:solidFill>
-                <a:latin typeface="JetBrains Mono"/>
+                <a:latin typeface="JetBrains Mono Medium"/>
               </a:rPr>
               <a:t>#0A4C76</a:t>
             </a:r>
@@ -5238,6 +5260,7 @@
           <a:lstStyle/>
           <a:p>
             <a:pPr algn="ctr"/>
+            <a:endParaRPr/>
           </a:p>
         </p:txBody>
       </p:sp>
@@ -5258,7 +5281,7 @@
           <a:noFill/>
         </p:spPr>
         <p:txBody>
-          <a:bodyPr wrap="square" anchor="t" lIns="0" rIns="0" tIns="0" bIns="0">
+          <a:bodyPr wrap="square" lIns="0" tIns="0" rIns="0" bIns="0" anchor="t">
             <a:spAutoFit/>
           </a:bodyPr>
           <a:lstStyle/>
@@ -5281,7 +5304,7 @@
                 <a:solidFill>
                   <a:srgbClr val="64748B"/>
                 </a:solidFill>
-                <a:latin typeface="JetBrains Mono"/>
+                <a:latin typeface="JetBrains Mono Medium"/>
               </a:rPr>
               <a:t>#1A7BB3</a:t>
             </a:r>
@@ -5329,6 +5352,7 @@
           <a:lstStyle/>
           <a:p>
             <a:pPr algn="ctr"/>
+            <a:endParaRPr/>
           </a:p>
         </p:txBody>
       </p:sp>
@@ -5349,7 +5373,7 @@
           <a:noFill/>
         </p:spPr>
         <p:txBody>
-          <a:bodyPr wrap="square" anchor="t" lIns="0" rIns="0" tIns="0" bIns="0">
+          <a:bodyPr wrap="square" lIns="0" tIns="0" rIns="0" bIns="0" anchor="t">
             <a:spAutoFit/>
           </a:bodyPr>
           <a:lstStyle/>
@@ -5372,7 +5396,7 @@
                 <a:solidFill>
                   <a:srgbClr val="64748B"/>
                 </a:solidFill>
-                <a:latin typeface="JetBrains Mono"/>
+                <a:latin typeface="JetBrains Mono Medium"/>
               </a:rPr>
               <a:t>#92CF93</a:t>
             </a:r>
@@ -5420,6 +5444,7 @@
           <a:lstStyle/>
           <a:p>
             <a:pPr algn="ctr"/>
+            <a:endParaRPr/>
           </a:p>
         </p:txBody>
       </p:sp>
@@ -5440,7 +5465,7 @@
           <a:noFill/>
         </p:spPr>
         <p:txBody>
-          <a:bodyPr wrap="square" anchor="t" lIns="0" rIns="0" tIns="0" bIns="0">
+          <a:bodyPr wrap="square" lIns="0" tIns="0" rIns="0" bIns="0" anchor="t">
             <a:spAutoFit/>
           </a:bodyPr>
           <a:lstStyle/>
@@ -5463,7 +5488,7 @@
                 <a:solidFill>
                   <a:srgbClr val="64748B"/>
                 </a:solidFill>
-                <a:latin typeface="JetBrains Mono"/>
+                <a:latin typeface="JetBrains Mono Medium"/>
               </a:rPr>
               <a:t>#F59E0B</a:t>
             </a:r>
@@ -5511,6 +5536,7 @@
           <a:lstStyle/>
           <a:p>
             <a:pPr algn="ctr"/>
+            <a:endParaRPr/>
           </a:p>
         </p:txBody>
       </p:sp>
@@ -5531,7 +5557,7 @@
           <a:noFill/>
         </p:spPr>
         <p:txBody>
-          <a:bodyPr wrap="square" anchor="t" lIns="0" rIns="0" tIns="0" bIns="0">
+          <a:bodyPr wrap="square" lIns="0" tIns="0" rIns="0" bIns="0" anchor="t">
             <a:spAutoFit/>
           </a:bodyPr>
           <a:lstStyle/>
@@ -5554,7 +5580,7 @@
                 <a:solidFill>
                   <a:srgbClr val="64748B"/>
                 </a:solidFill>
-                <a:latin typeface="JetBrains Mono"/>
+                <a:latin typeface="JetBrains Mono Medium"/>
               </a:rPr>
               <a:t>#EF4444</a:t>
             </a:r>
@@ -5578,7 +5604,7 @@
           <a:noFill/>
         </p:spPr>
         <p:txBody>
-          <a:bodyPr wrap="square" anchor="t" lIns="0" rIns="0" tIns="0" bIns="0">
+          <a:bodyPr wrap="square" lIns="0" tIns="0" rIns="0" bIns="0" anchor="t">
             <a:spAutoFit/>
           </a:bodyPr>
           <a:lstStyle/>
@@ -5589,9 +5615,9 @@
                 <a:solidFill>
                   <a:srgbClr val="0A4C76"/>
                 </a:solidFill>
-                <a:latin typeface="Unbounded"/>
-              </a:rPr>
-              <a:t>ПЛАНОМЕТРИКА</a:t>
+                <a:latin typeface="Unbounded Medium"/>
+              </a:rPr>
+              <a:t>Планометрика</a:t>
             </a:r>
           </a:p>
         </p:txBody>
@@ -5613,7 +5639,7 @@
           <a:noFill/>
         </p:spPr>
         <p:txBody>
-          <a:bodyPr wrap="square" anchor="t" lIns="0" rIns="0" tIns="0" bIns="0">
+          <a:bodyPr wrap="square" lIns="0" tIns="0" rIns="0" bIns="0" anchor="t">
             <a:spAutoFit/>
           </a:bodyPr>
           <a:lstStyle/>
@@ -5624,7 +5650,7 @@
                 <a:solidFill>
                   <a:srgbClr val="64748B"/>
                 </a:solidFill>
-                <a:latin typeface="JetBrains Mono"/>
+                <a:latin typeface="JetBrains Mono Medium"/>
               </a:rPr>
               <a:t>05</a:t>
             </a:r>
@@ -5640,7 +5666,7 @@
 </file>
 
 <file path=ppt/slides/slide6.xml><?xml version="1.0" encoding="utf-8"?>
-<p:sld xmlns:a="http://schemas.openxmlformats.org/drawingml/2006/main" xmlns:p="http://schemas.openxmlformats.org/presentationml/2006/main" xmlns:r="http://schemas.openxmlformats.org/officeDocument/2006/relationships">
+<p:sld xmlns:a="http://schemas.openxmlformats.org/drawingml/2006/main" xmlns:r="http://schemas.openxmlformats.org/officeDocument/2006/relationships" xmlns:p="http://schemas.openxmlformats.org/presentationml/2006/main">
   <p:cSld>
     <p:bg>
       <p:bgPr>
@@ -5656,7 +5682,14 @@
         <p:cNvGrpSpPr/>
         <p:nvPr/>
       </p:nvGrpSpPr>
-      <p:grpSpPr/>
+      <p:grpSpPr>
+        <a:xfrm>
+          <a:off x="0" y="0"/>
+          <a:ext cx="0" cy="0"/>
+          <a:chOff x="0" y="0"/>
+          <a:chExt cx="0" cy="0"/>
+        </a:xfrm>
+      </p:grpSpPr>
       <p:sp>
         <p:nvSpPr>
           <p:cNvPr id="2" name="TextBox 1"/>
@@ -5674,7 +5707,7 @@
           <a:noFill/>
         </p:spPr>
         <p:txBody>
-          <a:bodyPr wrap="square" anchor="t" lIns="0" rIns="0" tIns="0" bIns="0">
+          <a:bodyPr wrap="square" lIns="0" tIns="0" rIns="0" bIns="0" anchor="t">
             <a:spAutoFit/>
           </a:bodyPr>
           <a:lstStyle/>
@@ -5733,6 +5766,7 @@
           <a:lstStyle/>
           <a:p>
             <a:pPr algn="ctr"/>
+            <a:endParaRPr/>
           </a:p>
         </p:txBody>
       </p:sp>
@@ -5753,7 +5787,7 @@
           <a:noFill/>
         </p:spPr>
         <p:txBody>
-          <a:bodyPr wrap="square" anchor="t" lIns="0" rIns="0" tIns="0" bIns="0">
+          <a:bodyPr wrap="square" lIns="0" tIns="0" rIns="0" bIns="0" anchor="t">
             <a:spAutoFit/>
           </a:bodyPr>
           <a:lstStyle/>
@@ -5788,7 +5822,7 @@
           <a:noFill/>
         </p:spPr>
         <p:txBody>
-          <a:bodyPr wrap="square" anchor="t" lIns="0" rIns="0" tIns="0" bIns="0">
+          <a:bodyPr wrap="square" lIns="0" tIns="0" rIns="0" bIns="0" anchor="t">
             <a:spAutoFit/>
           </a:bodyPr>
           <a:lstStyle/>
@@ -5847,6 +5881,7 @@
           <a:lstStyle/>
           <a:p>
             <a:pPr algn="ctr"/>
+            <a:endParaRPr/>
           </a:p>
         </p:txBody>
       </p:sp>
@@ -5893,6 +5928,7 @@
           <a:lstStyle/>
           <a:p>
             <a:pPr algn="ctr"/>
+            <a:endParaRPr/>
           </a:p>
         </p:txBody>
       </p:sp>
@@ -5913,7 +5949,7 @@
           <a:noFill/>
         </p:spPr>
         <p:txBody>
-          <a:bodyPr wrap="square" anchor="t" lIns="0" rIns="0" tIns="0" bIns="0">
+          <a:bodyPr wrap="square" lIns="0" tIns="0" rIns="0" bIns="0" anchor="t">
             <a:spAutoFit/>
           </a:bodyPr>
           <a:lstStyle/>
@@ -5948,7 +5984,7 @@
           <a:noFill/>
         </p:spPr>
         <p:txBody>
-          <a:bodyPr wrap="square" anchor="t" lIns="0" rIns="0" tIns="0" bIns="0">
+          <a:bodyPr wrap="square" lIns="0" tIns="0" rIns="0" bIns="0" anchor="t">
             <a:spAutoFit/>
           </a:bodyPr>
           <a:lstStyle/>
@@ -5959,7 +5995,7 @@
                 <a:solidFill>
                   <a:srgbClr val="64748B"/>
                 </a:solidFill>
-                <a:latin typeface="JetBrains Mono"/>
+                <a:latin typeface="JetBrains Mono Medium"/>
               </a:rPr>
               <a:t>#FFFFFF</a:t>
             </a:r>
@@ -6009,6 +6045,7 @@
           <a:lstStyle/>
           <a:p>
             <a:pPr algn="ctr"/>
+            <a:endParaRPr/>
           </a:p>
         </p:txBody>
       </p:sp>
@@ -6029,7 +6066,7 @@
           <a:noFill/>
         </p:spPr>
         <p:txBody>
-          <a:bodyPr wrap="square" anchor="t" lIns="0" rIns="0" tIns="0" bIns="0">
+          <a:bodyPr wrap="square" lIns="0" tIns="0" rIns="0" bIns="0" anchor="t">
             <a:spAutoFit/>
           </a:bodyPr>
           <a:lstStyle/>
@@ -6064,7 +6101,7 @@
           <a:noFill/>
         </p:spPr>
         <p:txBody>
-          <a:bodyPr wrap="square" anchor="t" lIns="0" rIns="0" tIns="0" bIns="0">
+          <a:bodyPr wrap="square" lIns="0" tIns="0" rIns="0" bIns="0" anchor="t">
             <a:spAutoFit/>
           </a:bodyPr>
           <a:lstStyle/>
@@ -6075,7 +6112,7 @@
                 <a:solidFill>
                   <a:srgbClr val="64748B"/>
                 </a:solidFill>
-                <a:latin typeface="JetBrains Mono"/>
+                <a:latin typeface="JetBrains Mono Medium"/>
               </a:rPr>
               <a:t>#F0F9FF</a:t>
             </a:r>
@@ -6123,6 +6160,7 @@
           <a:lstStyle/>
           <a:p>
             <a:pPr algn="ctr"/>
+            <a:endParaRPr/>
           </a:p>
         </p:txBody>
       </p:sp>
@@ -6143,7 +6181,7 @@
           <a:noFill/>
         </p:spPr>
         <p:txBody>
-          <a:bodyPr wrap="square" anchor="t" lIns="0" rIns="0" tIns="0" bIns="0">
+          <a:bodyPr wrap="square" lIns="0" tIns="0" rIns="0" bIns="0" anchor="t">
             <a:spAutoFit/>
           </a:bodyPr>
           <a:lstStyle/>
@@ -6178,7 +6216,7 @@
           <a:noFill/>
         </p:spPr>
         <p:txBody>
-          <a:bodyPr wrap="square" anchor="t" lIns="0" rIns="0" tIns="0" bIns="0">
+          <a:bodyPr wrap="square" lIns="0" tIns="0" rIns="0" bIns="0" anchor="t">
             <a:spAutoFit/>
           </a:bodyPr>
           <a:lstStyle/>
@@ -6189,7 +6227,7 @@
                 <a:solidFill>
                   <a:srgbClr val="64748B"/>
                 </a:solidFill>
-                <a:latin typeface="JetBrains Mono"/>
+                <a:latin typeface="JetBrains Mono Medium"/>
               </a:rPr>
               <a:t>#E2E8F0</a:t>
             </a:r>
@@ -6239,6 +6277,7 @@
           <a:lstStyle/>
           <a:p>
             <a:pPr algn="ctr"/>
+            <a:endParaRPr/>
           </a:p>
         </p:txBody>
       </p:sp>
@@ -6259,7 +6298,7 @@
           <a:noFill/>
         </p:spPr>
         <p:txBody>
-          <a:bodyPr wrap="square" anchor="t" lIns="0" rIns="0" tIns="0" bIns="0">
+          <a:bodyPr wrap="square" lIns="0" tIns="0" rIns="0" bIns="0" anchor="t">
             <a:spAutoFit/>
           </a:bodyPr>
           <a:lstStyle/>
@@ -6294,7 +6333,7 @@
           <a:noFill/>
         </p:spPr>
         <p:txBody>
-          <a:bodyPr wrap="square" anchor="t" lIns="0" rIns="0" tIns="0" bIns="0">
+          <a:bodyPr wrap="square" lIns="0" tIns="0" rIns="0" bIns="0" anchor="t">
             <a:spAutoFit/>
           </a:bodyPr>
           <a:lstStyle/>
@@ -6305,7 +6344,7 @@
                 <a:solidFill>
                   <a:srgbClr val="64748B"/>
                 </a:solidFill>
-                <a:latin typeface="JetBrains Mono"/>
+                <a:latin typeface="JetBrains Mono Medium"/>
               </a:rPr>
               <a:t>#FAFAFA</a:t>
             </a:r>
@@ -6353,6 +6392,7 @@
           <a:lstStyle/>
           <a:p>
             <a:pPr algn="ctr"/>
+            <a:endParaRPr/>
           </a:p>
         </p:txBody>
       </p:sp>
@@ -6373,7 +6413,7 @@
           <a:noFill/>
         </p:spPr>
         <p:txBody>
-          <a:bodyPr wrap="square" anchor="t" lIns="0" rIns="0" tIns="0" bIns="0">
+          <a:bodyPr wrap="square" lIns="0" tIns="0" rIns="0" bIns="0" anchor="t">
             <a:spAutoFit/>
           </a:bodyPr>
           <a:lstStyle/>
@@ -6408,7 +6448,7 @@
           <a:noFill/>
         </p:spPr>
         <p:txBody>
-          <a:bodyPr wrap="square" anchor="t" lIns="0" rIns="0" tIns="0" bIns="0">
+          <a:bodyPr wrap="square" lIns="0" tIns="0" rIns="0" bIns="0" anchor="t">
             <a:spAutoFit/>
           </a:bodyPr>
           <a:lstStyle/>
@@ -6419,7 +6459,7 @@
                 <a:solidFill>
                   <a:srgbClr val="64748B"/>
                 </a:solidFill>
-                <a:latin typeface="JetBrains Mono"/>
+                <a:latin typeface="JetBrains Mono Medium"/>
               </a:rPr>
               <a:t>#64748B</a:t>
             </a:r>
@@ -6467,6 +6507,7 @@
           <a:lstStyle/>
           <a:p>
             <a:pPr algn="ctr"/>
+            <a:endParaRPr/>
           </a:p>
         </p:txBody>
       </p:sp>
@@ -6487,7 +6528,7 @@
           <a:noFill/>
         </p:spPr>
         <p:txBody>
-          <a:bodyPr wrap="square" anchor="t" lIns="0" rIns="0" tIns="0" bIns="0">
+          <a:bodyPr wrap="square" lIns="0" tIns="0" rIns="0" bIns="0" anchor="t">
             <a:spAutoFit/>
           </a:bodyPr>
           <a:lstStyle/>
@@ -6522,7 +6563,7 @@
           <a:noFill/>
         </p:spPr>
         <p:txBody>
-          <a:bodyPr wrap="square" anchor="t" lIns="0" rIns="0" tIns="0" bIns="0">
+          <a:bodyPr wrap="square" lIns="0" tIns="0" rIns="0" bIns="0" anchor="t">
             <a:spAutoFit/>
           </a:bodyPr>
           <a:lstStyle/>
@@ -6533,7 +6574,7 @@
                 <a:solidFill>
                   <a:srgbClr val="64748B"/>
                 </a:solidFill>
-                <a:latin typeface="JetBrains Mono"/>
+                <a:latin typeface="JetBrains Mono Medium"/>
               </a:rPr>
               <a:t>#EF4444</a:t>
             </a:r>
@@ -6581,6 +6622,7 @@
           <a:lstStyle/>
           <a:p>
             <a:pPr algn="ctr"/>
+            <a:endParaRPr/>
           </a:p>
         </p:txBody>
       </p:sp>
@@ -6601,7 +6643,7 @@
           <a:noFill/>
         </p:spPr>
         <p:txBody>
-          <a:bodyPr wrap="square" anchor="t" lIns="0" rIns="0" tIns="0" bIns="0">
+          <a:bodyPr wrap="square" lIns="0" tIns="0" rIns="0" bIns="0" anchor="t">
             <a:spAutoFit/>
           </a:bodyPr>
           <a:lstStyle/>
@@ -6636,7 +6678,7 @@
           <a:noFill/>
         </p:spPr>
         <p:txBody>
-          <a:bodyPr wrap="square" anchor="t" lIns="0" rIns="0" tIns="0" bIns="0">
+          <a:bodyPr wrap="square" lIns="0" tIns="0" rIns="0" bIns="0" anchor="t">
             <a:spAutoFit/>
           </a:bodyPr>
           <a:lstStyle/>
@@ -6647,7 +6689,7 @@
                 <a:solidFill>
                   <a:srgbClr val="64748B"/>
                 </a:solidFill>
-                <a:latin typeface="JetBrains Mono"/>
+                <a:latin typeface="JetBrains Mono Medium"/>
               </a:rPr>
               <a:t>#0A4C76</a:t>
             </a:r>
@@ -6697,6 +6739,7 @@
           <a:lstStyle/>
           <a:p>
             <a:pPr algn="ctr"/>
+            <a:endParaRPr/>
           </a:p>
         </p:txBody>
       </p:sp>
@@ -6717,7 +6760,7 @@
           <a:noFill/>
         </p:spPr>
         <p:txBody>
-          <a:bodyPr wrap="square" anchor="t" lIns="0" rIns="0" tIns="0" bIns="0">
+          <a:bodyPr wrap="square" lIns="0" tIns="0" rIns="0" bIns="0" anchor="t">
             <a:spAutoFit/>
           </a:bodyPr>
           <a:lstStyle/>
@@ -6752,7 +6795,7 @@
           <a:noFill/>
         </p:spPr>
         <p:txBody>
-          <a:bodyPr wrap="square" anchor="t" lIns="0" rIns="0" tIns="0" bIns="0">
+          <a:bodyPr wrap="square" lIns="0" tIns="0" rIns="0" bIns="0" anchor="t">
             <a:spAutoFit/>
           </a:bodyPr>
           <a:lstStyle/>
@@ -6763,7 +6806,7 @@
                 <a:solidFill>
                   <a:srgbClr val="94A3B8"/>
                 </a:solidFill>
-                <a:latin typeface="JetBrains Mono"/>
+                <a:latin typeface="JetBrains Mono Medium"/>
               </a:rPr>
               <a:t>#0F172A</a:t>
             </a:r>
@@ -6811,6 +6854,7 @@
           <a:lstStyle/>
           <a:p>
             <a:pPr algn="ctr"/>
+            <a:endParaRPr/>
           </a:p>
         </p:txBody>
       </p:sp>
@@ -6831,7 +6875,7 @@
           <a:noFill/>
         </p:spPr>
         <p:txBody>
-          <a:bodyPr wrap="square" anchor="t" lIns="0" rIns="0" tIns="0" bIns="0">
+          <a:bodyPr wrap="square" lIns="0" tIns="0" rIns="0" bIns="0" anchor="t">
             <a:spAutoFit/>
           </a:bodyPr>
           <a:lstStyle/>
@@ -6866,7 +6910,7 @@
           <a:noFill/>
         </p:spPr>
         <p:txBody>
-          <a:bodyPr wrap="square" anchor="t" lIns="0" rIns="0" tIns="0" bIns="0">
+          <a:bodyPr wrap="square" lIns="0" tIns="0" rIns="0" bIns="0" anchor="t">
             <a:spAutoFit/>
           </a:bodyPr>
           <a:lstStyle/>
@@ -6877,7 +6921,7 @@
                 <a:solidFill>
                   <a:srgbClr val="94A3B8"/>
                 </a:solidFill>
-                <a:latin typeface="JetBrains Mono"/>
+                <a:latin typeface="JetBrains Mono Medium"/>
               </a:rPr>
               <a:t>#1E293B</a:t>
             </a:r>
@@ -6925,6 +6969,7 @@
           <a:lstStyle/>
           <a:p>
             <a:pPr algn="ctr"/>
+            <a:endParaRPr/>
           </a:p>
         </p:txBody>
       </p:sp>
@@ -6945,7 +6990,7 @@
           <a:noFill/>
         </p:spPr>
         <p:txBody>
-          <a:bodyPr wrap="square" anchor="t" lIns="0" rIns="0" tIns="0" bIns="0">
+          <a:bodyPr wrap="square" lIns="0" tIns="0" rIns="0" bIns="0" anchor="t">
             <a:spAutoFit/>
           </a:bodyPr>
           <a:lstStyle/>
@@ -6980,7 +7025,7 @@
           <a:noFill/>
         </p:spPr>
         <p:txBody>
-          <a:bodyPr wrap="square" anchor="t" lIns="0" rIns="0" tIns="0" bIns="0">
+          <a:bodyPr wrap="square" lIns="0" tIns="0" rIns="0" bIns="0" anchor="t">
             <a:spAutoFit/>
           </a:bodyPr>
           <a:lstStyle/>
@@ -6991,7 +7036,7 @@
                 <a:solidFill>
                   <a:srgbClr val="94A3B8"/>
                 </a:solidFill>
-                <a:latin typeface="JetBrains Mono"/>
+                <a:latin typeface="JetBrains Mono Medium"/>
               </a:rPr>
               <a:t>#334155</a:t>
             </a:r>
@@ -7039,6 +7084,7 @@
           <a:lstStyle/>
           <a:p>
             <a:pPr algn="ctr"/>
+            <a:endParaRPr/>
           </a:p>
         </p:txBody>
       </p:sp>
@@ -7059,7 +7105,7 @@
           <a:noFill/>
         </p:spPr>
         <p:txBody>
-          <a:bodyPr wrap="square" anchor="t" lIns="0" rIns="0" tIns="0" bIns="0">
+          <a:bodyPr wrap="square" lIns="0" tIns="0" rIns="0" bIns="0" anchor="t">
             <a:spAutoFit/>
           </a:bodyPr>
           <a:lstStyle/>
@@ -7094,7 +7140,7 @@
           <a:noFill/>
         </p:spPr>
         <p:txBody>
-          <a:bodyPr wrap="square" anchor="t" lIns="0" rIns="0" tIns="0" bIns="0">
+          <a:bodyPr wrap="square" lIns="0" tIns="0" rIns="0" bIns="0" anchor="t">
             <a:spAutoFit/>
           </a:bodyPr>
           <a:lstStyle/>
@@ -7105,7 +7151,7 @@
                 <a:solidFill>
                   <a:srgbClr val="94A3B8"/>
                 </a:solidFill>
-                <a:latin typeface="JetBrains Mono"/>
+                <a:latin typeface="JetBrains Mono Medium"/>
               </a:rPr>
               <a:t>#3B82F6</a:t>
             </a:r>
@@ -7153,6 +7199,7 @@
           <a:lstStyle/>
           <a:p>
             <a:pPr algn="ctr"/>
+            <a:endParaRPr/>
           </a:p>
         </p:txBody>
       </p:sp>
@@ -7173,7 +7220,7 @@
           <a:noFill/>
         </p:spPr>
         <p:txBody>
-          <a:bodyPr wrap="square" anchor="t" lIns="0" rIns="0" tIns="0" bIns="0">
+          <a:bodyPr wrap="square" lIns="0" tIns="0" rIns="0" bIns="0" anchor="t">
             <a:spAutoFit/>
           </a:bodyPr>
           <a:lstStyle/>
@@ -7208,7 +7255,7 @@
           <a:noFill/>
         </p:spPr>
         <p:txBody>
-          <a:bodyPr wrap="square" anchor="t" lIns="0" rIns="0" tIns="0" bIns="0">
+          <a:bodyPr wrap="square" lIns="0" tIns="0" rIns="0" bIns="0" anchor="t">
             <a:spAutoFit/>
           </a:bodyPr>
           <a:lstStyle/>
@@ -7219,7 +7266,7 @@
                 <a:solidFill>
                   <a:srgbClr val="94A3B8"/>
                 </a:solidFill>
-                <a:latin typeface="JetBrains Mono"/>
+                <a:latin typeface="JetBrains Mono Medium"/>
               </a:rPr>
               <a:t>#94A3B8</a:t>
             </a:r>
@@ -7267,6 +7314,7 @@
           <a:lstStyle/>
           <a:p>
             <a:pPr algn="ctr"/>
+            <a:endParaRPr/>
           </a:p>
         </p:txBody>
       </p:sp>
@@ -7287,7 +7335,7 @@
           <a:noFill/>
         </p:spPr>
         <p:txBody>
-          <a:bodyPr wrap="square" anchor="t" lIns="0" rIns="0" tIns="0" bIns="0">
+          <a:bodyPr wrap="square" lIns="0" tIns="0" rIns="0" bIns="0" anchor="t">
             <a:spAutoFit/>
           </a:bodyPr>
           <a:lstStyle/>
@@ -7322,7 +7370,7 @@
           <a:noFill/>
         </p:spPr>
         <p:txBody>
-          <a:bodyPr wrap="square" anchor="t" lIns="0" rIns="0" tIns="0" bIns="0">
+          <a:bodyPr wrap="square" lIns="0" tIns="0" rIns="0" bIns="0" anchor="t">
             <a:spAutoFit/>
           </a:bodyPr>
           <a:lstStyle/>
@@ -7333,7 +7381,7 @@
                 <a:solidFill>
                   <a:srgbClr val="94A3B8"/>
                 </a:solidFill>
-                <a:latin typeface="JetBrains Mono"/>
+                <a:latin typeface="JetBrains Mono Medium"/>
               </a:rPr>
               <a:t>#7F1D1D</a:t>
             </a:r>
@@ -7381,6 +7429,7 @@
           <a:lstStyle/>
           <a:p>
             <a:pPr algn="ctr"/>
+            <a:endParaRPr/>
           </a:p>
         </p:txBody>
       </p:sp>
@@ -7401,7 +7450,7 @@
           <a:noFill/>
         </p:spPr>
         <p:txBody>
-          <a:bodyPr wrap="square" anchor="t" lIns="0" rIns="0" tIns="0" bIns="0">
+          <a:bodyPr wrap="square" lIns="0" tIns="0" rIns="0" bIns="0" anchor="t">
             <a:spAutoFit/>
           </a:bodyPr>
           <a:lstStyle/>
@@ -7436,7 +7485,7 @@
           <a:noFill/>
         </p:spPr>
         <p:txBody>
-          <a:bodyPr wrap="square" anchor="t" lIns="0" rIns="0" tIns="0" bIns="0">
+          <a:bodyPr wrap="square" lIns="0" tIns="0" rIns="0" bIns="0" anchor="t">
             <a:spAutoFit/>
           </a:bodyPr>
           <a:lstStyle/>
@@ -7447,7 +7496,7 @@
                 <a:solidFill>
                   <a:srgbClr val="94A3B8"/>
                 </a:solidFill>
-                <a:latin typeface="JetBrains Mono"/>
+                <a:latin typeface="JetBrains Mono Medium"/>
               </a:rPr>
               <a:t>#F8FAFC</a:t>
             </a:r>
@@ -7471,7 +7520,7 @@
           <a:noFill/>
         </p:spPr>
         <p:txBody>
-          <a:bodyPr wrap="square" anchor="t" lIns="0" rIns="0" tIns="0" bIns="0">
+          <a:bodyPr wrap="square" lIns="0" tIns="0" rIns="0" bIns="0" anchor="t">
             <a:spAutoFit/>
           </a:bodyPr>
           <a:lstStyle/>
@@ -7482,9 +7531,9 @@
                 <a:solidFill>
                   <a:srgbClr val="0A4C76"/>
                 </a:solidFill>
-                <a:latin typeface="Unbounded"/>
-              </a:rPr>
-              <a:t>ПЛАНОМЕТРИКА</a:t>
+                <a:latin typeface="Unbounded Medium"/>
+              </a:rPr>
+              <a:t>Планометрика</a:t>
             </a:r>
           </a:p>
         </p:txBody>
@@ -7506,7 +7555,7 @@
           <a:noFill/>
         </p:spPr>
         <p:txBody>
-          <a:bodyPr wrap="square" anchor="t" lIns="0" rIns="0" tIns="0" bIns="0">
+          <a:bodyPr wrap="square" lIns="0" tIns="0" rIns="0" bIns="0" anchor="t">
             <a:spAutoFit/>
           </a:bodyPr>
           <a:lstStyle/>
@@ -7517,7 +7566,7 @@
                 <a:solidFill>
                   <a:srgbClr val="64748B"/>
                 </a:solidFill>
-                <a:latin typeface="JetBrains Mono"/>
+                <a:latin typeface="JetBrains Mono Medium"/>
               </a:rPr>
               <a:t>06</a:t>
             </a:r>
@@ -7533,7 +7582,7 @@
 </file>
 
 <file path=ppt/slides/slide7.xml><?xml version="1.0" encoding="utf-8"?>
-<p:sld xmlns:a="http://schemas.openxmlformats.org/drawingml/2006/main" xmlns:p="http://schemas.openxmlformats.org/presentationml/2006/main" xmlns:r="http://schemas.openxmlformats.org/officeDocument/2006/relationships">
+<p:sld xmlns:a="http://schemas.openxmlformats.org/drawingml/2006/main" xmlns:r="http://schemas.openxmlformats.org/officeDocument/2006/relationships" xmlns:p="http://schemas.openxmlformats.org/presentationml/2006/main">
   <p:cSld>
     <p:bg>
       <p:bgPr>
@@ -7549,7 +7598,14 @@
         <p:cNvGrpSpPr/>
         <p:nvPr/>
       </p:nvGrpSpPr>
-      <p:grpSpPr/>
+      <p:grpSpPr>
+        <a:xfrm>
+          <a:off x="0" y="0"/>
+          <a:ext cx="0" cy="0"/>
+          <a:chOff x="0" y="0"/>
+          <a:chExt cx="0" cy="0"/>
+        </a:xfrm>
+      </p:grpSpPr>
       <p:sp>
         <p:nvSpPr>
           <p:cNvPr id="2" name="TextBox 1"/>
@@ -7567,7 +7623,7 @@
           <a:noFill/>
         </p:spPr>
         <p:txBody>
-          <a:bodyPr wrap="square" anchor="t" lIns="0" rIns="0" tIns="0" bIns="0">
+          <a:bodyPr wrap="square" lIns="0" tIns="0" rIns="0" bIns="0" anchor="t">
             <a:spAutoFit/>
           </a:bodyPr>
           <a:lstStyle/>
@@ -7626,6 +7682,7 @@
           <a:lstStyle/>
           <a:p>
             <a:pPr algn="ctr"/>
+            <a:endParaRPr/>
           </a:p>
         </p:txBody>
       </p:sp>
@@ -7643,7 +7700,7 @@
         </p:xfrm>
         <a:graphic>
           <a:graphicData uri="http://schemas.openxmlformats.org/drawingml/2006/chart">
-            <c:chart xmlns:c="http://schemas.openxmlformats.org/drawingml/2006/chart" r:id="rId2"/>
+            <c:chart xmlns:c="http://schemas.openxmlformats.org/drawingml/2006/chart" xmlns:r="http://schemas.openxmlformats.org/officeDocument/2006/relationships" r:id="rId2"/>
           </a:graphicData>
         </a:graphic>
       </p:graphicFrame>
@@ -7664,7 +7721,7 @@
           <a:noFill/>
         </p:spPr>
         <p:txBody>
-          <a:bodyPr wrap="square" anchor="t" lIns="0" rIns="0" tIns="0" bIns="0">
+          <a:bodyPr wrap="square" lIns="0" tIns="0" rIns="0" bIns="0" anchor="t">
             <a:spAutoFit/>
           </a:bodyPr>
           <a:lstStyle/>
@@ -7675,9 +7732,9 @@
                 <a:solidFill>
                   <a:srgbClr val="0A4C76"/>
                 </a:solidFill>
-                <a:latin typeface="Unbounded"/>
-              </a:rPr>
-              <a:t>ПЛАНОМЕТРИКА</a:t>
+                <a:latin typeface="Unbounded Medium"/>
+              </a:rPr>
+              <a:t>Планометрика</a:t>
             </a:r>
           </a:p>
         </p:txBody>
@@ -7699,7 +7756,7 @@
           <a:noFill/>
         </p:spPr>
         <p:txBody>
-          <a:bodyPr wrap="square" anchor="t" lIns="0" rIns="0" tIns="0" bIns="0">
+          <a:bodyPr wrap="square" lIns="0" tIns="0" rIns="0" bIns="0" anchor="t">
             <a:spAutoFit/>
           </a:bodyPr>
           <a:lstStyle/>
@@ -7710,7 +7767,7 @@
                 <a:solidFill>
                   <a:srgbClr val="64748B"/>
                 </a:solidFill>
-                <a:latin typeface="JetBrains Mono"/>
+                <a:latin typeface="JetBrains Mono Medium"/>
               </a:rPr>
               <a:t>07</a:t>
             </a:r>
@@ -7726,7 +7783,7 @@
 </file>
 
 <file path=ppt/slides/slide8.xml><?xml version="1.0" encoding="utf-8"?>
-<p:sld xmlns:a="http://schemas.openxmlformats.org/drawingml/2006/main" xmlns:p="http://schemas.openxmlformats.org/presentationml/2006/main" xmlns:r="http://schemas.openxmlformats.org/officeDocument/2006/relationships">
+<p:sld xmlns:a="http://schemas.openxmlformats.org/drawingml/2006/main" xmlns:r="http://schemas.openxmlformats.org/officeDocument/2006/relationships" xmlns:p="http://schemas.openxmlformats.org/presentationml/2006/main">
   <p:cSld>
     <p:bg>
       <p:bgPr>
@@ -7742,7 +7799,14 @@
         <p:cNvGrpSpPr/>
         <p:nvPr/>
       </p:nvGrpSpPr>
-      <p:grpSpPr/>
+      <p:grpSpPr>
+        <a:xfrm>
+          <a:off x="0" y="0"/>
+          <a:ext cx="0" cy="0"/>
+          <a:chOff x="0" y="0"/>
+          <a:chExt cx="0" cy="0"/>
+        </a:xfrm>
+      </p:grpSpPr>
       <p:sp>
         <p:nvSpPr>
           <p:cNvPr id="2" name="TextBox 1"/>
@@ -7760,7 +7824,7 @@
           <a:noFill/>
         </p:spPr>
         <p:txBody>
-          <a:bodyPr wrap="square" anchor="t" lIns="0" rIns="0" tIns="0" bIns="0">
+          <a:bodyPr wrap="square" lIns="0" tIns="0" rIns="0" bIns="0" anchor="t">
             <a:spAutoFit/>
           </a:bodyPr>
           <a:lstStyle/>
@@ -7819,6 +7883,7 @@
           <a:lstStyle/>
           <a:p>
             <a:pPr algn="ctr"/>
+            <a:endParaRPr/>
           </a:p>
         </p:txBody>
       </p:sp>
@@ -7841,10 +7906,34 @@
                 <a:tableStyleId>{5C22544A-7EE6-4342-B048-85BDC9FD1C3A}</a:tableStyleId>
               </a:tblPr>
               <a:tblGrid>
-                <a:gridCol w="2766060"/>
-                <a:gridCol w="2766060"/>
-                <a:gridCol w="2766060"/>
-                <a:gridCol w="2766060"/>
+                <a:gridCol w="2766060">
+                  <a:extLst>
+                    <a:ext uri="{9D8B030D-6E8A-4147-A177-3AD203B41FA5}">
+                      <a16:colId xmlns:a16="http://schemas.microsoft.com/office/drawing/2014/main" val="20000"/>
+                    </a:ext>
+                  </a:extLst>
+                </a:gridCol>
+                <a:gridCol w="2766060">
+                  <a:extLst>
+                    <a:ext uri="{9D8B030D-6E8A-4147-A177-3AD203B41FA5}">
+                      <a16:colId xmlns:a16="http://schemas.microsoft.com/office/drawing/2014/main" val="20001"/>
+                    </a:ext>
+                  </a:extLst>
+                </a:gridCol>
+                <a:gridCol w="2766060">
+                  <a:extLst>
+                    <a:ext uri="{9D8B030D-6E8A-4147-A177-3AD203B41FA5}">
+                      <a16:colId xmlns:a16="http://schemas.microsoft.com/office/drawing/2014/main" val="20002"/>
+                    </a:ext>
+                  </a:extLst>
+                </a:gridCol>
+                <a:gridCol w="2766060">
+                  <a:extLst>
+                    <a:ext uri="{9D8B030D-6E8A-4147-A177-3AD203B41FA5}">
+                      <a16:colId xmlns:a16="http://schemas.microsoft.com/office/drawing/2014/main" val="20003"/>
+                    </a:ext>
+                  </a:extLst>
+                </a:gridCol>
               </a:tblGrid>
               <a:tr h="658368">
                 <a:tc>
@@ -7935,6 +8024,11 @@
                     </a:solidFill>
                   </a:tcPr>
                 </a:tc>
+                <a:extLst>
+                  <a:ext uri="{0D108BD9-81ED-4DB2-BD59-A6C34878D82A}">
+                    <a16:rowId xmlns:a16="http://schemas.microsoft.com/office/drawing/2014/main" val="10000"/>
+                  </a:ext>
+                </a:extLst>
               </a:tr>
               <a:tr h="658368">
                 <a:tc>
@@ -7947,7 +8041,7 @@
                           <a:solidFill>
                             <a:srgbClr val="0F172A"/>
                           </a:solidFill>
-                          <a:latin typeface="JetBrains Mono"/>
+                          <a:latin typeface="JetBrains Mono Medium"/>
                         </a:rPr>
                         <a:t>Выручка, млн ₽</a:t>
                       </a:r>
@@ -7969,7 +8063,7 @@
                           <a:solidFill>
                             <a:srgbClr val="0F172A"/>
                           </a:solidFill>
-                          <a:latin typeface="JetBrains Mono"/>
+                          <a:latin typeface="JetBrains Mono Medium"/>
                         </a:rPr>
                         <a:t>12,4</a:t>
                       </a:r>
@@ -7991,7 +8085,7 @@
                           <a:solidFill>
                             <a:srgbClr val="0F172A"/>
                           </a:solidFill>
-                          <a:latin typeface="JetBrains Mono"/>
+                          <a:latin typeface="JetBrains Mono Medium"/>
                         </a:rPr>
                         <a:t>18,9</a:t>
                       </a:r>
@@ -8013,7 +8107,7 @@
                           <a:solidFill>
                             <a:srgbClr val="0F172A"/>
                           </a:solidFill>
-                          <a:latin typeface="JetBrains Mono"/>
+                          <a:latin typeface="JetBrains Mono Medium"/>
                         </a:rPr>
                         <a:t>27,3</a:t>
                       </a:r>
@@ -8025,6 +8119,11 @@
                     </a:solidFill>
                   </a:tcPr>
                 </a:tc>
+                <a:extLst>
+                  <a:ext uri="{0D108BD9-81ED-4DB2-BD59-A6C34878D82A}">
+                    <a16:rowId xmlns:a16="http://schemas.microsoft.com/office/drawing/2014/main" val="10001"/>
+                  </a:ext>
+                </a:extLst>
               </a:tr>
               <a:tr h="658368">
                 <a:tc>
@@ -8037,7 +8136,7 @@
                           <a:solidFill>
                             <a:srgbClr val="0F172A"/>
                           </a:solidFill>
-                          <a:latin typeface="JetBrains Mono"/>
+                          <a:latin typeface="JetBrains Mono Medium"/>
                         </a:rPr>
                         <a:t>Проекты</a:t>
                       </a:r>
@@ -8059,7 +8158,7 @@
                           <a:solidFill>
                             <a:srgbClr val="0F172A"/>
                           </a:solidFill>
-                          <a:latin typeface="JetBrains Mono"/>
+                          <a:latin typeface="JetBrains Mono Medium"/>
                         </a:rPr>
                         <a:t>86</a:t>
                       </a:r>
@@ -8081,7 +8180,7 @@
                           <a:solidFill>
                             <a:srgbClr val="0F172A"/>
                           </a:solidFill>
-                          <a:latin typeface="JetBrains Mono"/>
+                          <a:latin typeface="JetBrains Mono Medium"/>
                         </a:rPr>
                         <a:t>142</a:t>
                       </a:r>
@@ -8103,7 +8202,7 @@
                           <a:solidFill>
                             <a:srgbClr val="0F172A"/>
                           </a:solidFill>
-                          <a:latin typeface="JetBrains Mono"/>
+                          <a:latin typeface="JetBrains Mono Medium"/>
                         </a:rPr>
                         <a:t>210</a:t>
                       </a:r>
@@ -8115,6 +8214,11 @@
                     </a:solidFill>
                   </a:tcPr>
                 </a:tc>
+                <a:extLst>
+                  <a:ext uri="{0D108BD9-81ED-4DB2-BD59-A6C34878D82A}">
+                    <a16:rowId xmlns:a16="http://schemas.microsoft.com/office/drawing/2014/main" val="10002"/>
+                  </a:ext>
+                </a:extLst>
               </a:tr>
               <a:tr h="658368">
                 <a:tc>
@@ -8127,7 +8231,7 @@
                           <a:solidFill>
                             <a:srgbClr val="0F172A"/>
                           </a:solidFill>
-                          <a:latin typeface="JetBrains Mono"/>
+                          <a:latin typeface="JetBrains Mono Medium"/>
                         </a:rPr>
                         <a:t>Партнёры</a:t>
                       </a:r>
@@ -8149,7 +8253,7 @@
                           <a:solidFill>
                             <a:srgbClr val="0F172A"/>
                           </a:solidFill>
-                          <a:latin typeface="JetBrains Mono"/>
+                          <a:latin typeface="JetBrains Mono Medium"/>
                         </a:rPr>
                         <a:t>14</a:t>
                       </a:r>
@@ -8171,7 +8275,7 @@
                           <a:solidFill>
                             <a:srgbClr val="0F172A"/>
                           </a:solidFill>
-                          <a:latin typeface="JetBrains Mono"/>
+                          <a:latin typeface="JetBrains Mono Medium"/>
                         </a:rPr>
                         <a:t>31</a:t>
                       </a:r>
@@ -8193,7 +8297,7 @@
                           <a:solidFill>
                             <a:srgbClr val="0F172A"/>
                           </a:solidFill>
-                          <a:latin typeface="JetBrains Mono"/>
+                          <a:latin typeface="JetBrains Mono Medium"/>
                         </a:rPr>
                         <a:t>58</a:t>
                       </a:r>
@@ -8205,6 +8309,11 @@
                     </a:solidFill>
                   </a:tcPr>
                 </a:tc>
+                <a:extLst>
+                  <a:ext uri="{0D108BD9-81ED-4DB2-BD59-A6C34878D82A}">
+                    <a16:rowId xmlns:a16="http://schemas.microsoft.com/office/drawing/2014/main" val="10003"/>
+                  </a:ext>
+                </a:extLst>
               </a:tr>
               <a:tr h="658368">
                 <a:tc>
@@ -8217,7 +8326,7 @@
                           <a:solidFill>
                             <a:srgbClr val="0F172A"/>
                           </a:solidFill>
-                          <a:latin typeface="JetBrains Mono"/>
+                          <a:latin typeface="JetBrains Mono Medium"/>
                         </a:rPr>
                         <a:t>NPS</a:t>
                       </a:r>
@@ -8239,7 +8348,7 @@
                           <a:solidFill>
                             <a:srgbClr val="0F172A"/>
                           </a:solidFill>
-                          <a:latin typeface="JetBrains Mono"/>
+                          <a:latin typeface="JetBrains Mono Medium"/>
                         </a:rPr>
                         <a:t>62</a:t>
                       </a:r>
@@ -8261,7 +8370,7 @@
                           <a:solidFill>
                             <a:srgbClr val="0F172A"/>
                           </a:solidFill>
-                          <a:latin typeface="JetBrains Mono"/>
+                          <a:latin typeface="JetBrains Mono Medium"/>
                         </a:rPr>
                         <a:t>71</a:t>
                       </a:r>
@@ -8283,7 +8392,7 @@
                           <a:solidFill>
                             <a:srgbClr val="0F172A"/>
                           </a:solidFill>
-                          <a:latin typeface="JetBrains Mono"/>
+                          <a:latin typeface="JetBrains Mono Medium"/>
                         </a:rPr>
                         <a:t>78</a:t>
                       </a:r>
@@ -8295,6 +8404,11 @@
                     </a:solidFill>
                   </a:tcPr>
                 </a:tc>
+                <a:extLst>
+                  <a:ext uri="{0D108BD9-81ED-4DB2-BD59-A6C34878D82A}">
+                    <a16:rowId xmlns:a16="http://schemas.microsoft.com/office/drawing/2014/main" val="10004"/>
+                  </a:ext>
+                </a:extLst>
               </a:tr>
             </a:tbl>
           </a:graphicData>
@@ -8317,7 +8431,7 @@
           <a:noFill/>
         </p:spPr>
         <p:txBody>
-          <a:bodyPr wrap="square" anchor="t" lIns="0" rIns="0" tIns="0" bIns="0">
+          <a:bodyPr wrap="square" lIns="0" tIns="0" rIns="0" bIns="0" anchor="t">
             <a:spAutoFit/>
           </a:bodyPr>
           <a:lstStyle/>
@@ -8328,9 +8442,9 @@
                 <a:solidFill>
                   <a:srgbClr val="0A4C76"/>
                 </a:solidFill>
-                <a:latin typeface="Unbounded"/>
-              </a:rPr>
-              <a:t>ПЛАНОМЕТРИКА</a:t>
+                <a:latin typeface="Unbounded Medium"/>
+              </a:rPr>
+              <a:t>Планометрика</a:t>
             </a:r>
           </a:p>
         </p:txBody>
@@ -8352,7 +8466,7 @@
           <a:noFill/>
         </p:spPr>
         <p:txBody>
-          <a:bodyPr wrap="square" anchor="t" lIns="0" rIns="0" tIns="0" bIns="0">
+          <a:bodyPr wrap="square" lIns="0" tIns="0" rIns="0" bIns="0" anchor="t">
             <a:spAutoFit/>
           </a:bodyPr>
           <a:lstStyle/>
@@ -8363,7 +8477,7 @@
                 <a:solidFill>
                   <a:srgbClr val="64748B"/>
                 </a:solidFill>
-                <a:latin typeface="JetBrains Mono"/>
+                <a:latin typeface="JetBrains Mono Medium"/>
               </a:rPr>
               <a:t>08</a:t>
             </a:r>
@@ -8379,7 +8493,7 @@
 </file>
 
 <file path=ppt/slides/slide9.xml><?xml version="1.0" encoding="utf-8"?>
-<p:sld xmlns:a="http://schemas.openxmlformats.org/drawingml/2006/main" xmlns:p="http://schemas.openxmlformats.org/presentationml/2006/main" xmlns:r="http://schemas.openxmlformats.org/officeDocument/2006/relationships">
+<p:sld xmlns:a="http://schemas.openxmlformats.org/drawingml/2006/main" xmlns:r="http://schemas.openxmlformats.org/officeDocument/2006/relationships" xmlns:p="http://schemas.openxmlformats.org/presentationml/2006/main">
   <p:cSld>
     <p:bg>
       <p:bgPr>
@@ -8395,7 +8509,14 @@
         <p:cNvGrpSpPr/>
         <p:nvPr/>
       </p:nvGrpSpPr>
-      <p:grpSpPr/>
+      <p:grpSpPr>
+        <a:xfrm>
+          <a:off x="0" y="0"/>
+          <a:ext cx="0" cy="0"/>
+          <a:chOff x="0" y="0"/>
+          <a:chExt cx="0" cy="0"/>
+        </a:xfrm>
+      </p:grpSpPr>
       <p:sp>
         <p:nvSpPr>
           <p:cNvPr id="2" name="Rectangle 1"/>
@@ -8437,6 +8558,7 @@
           <a:lstStyle/>
           <a:p>
             <a:pPr algn="ctr"/>
+            <a:endParaRPr/>
           </a:p>
         </p:txBody>
       </p:sp>
@@ -8457,7 +8579,7 @@
           <a:noFill/>
         </p:spPr>
         <p:txBody>
-          <a:bodyPr wrap="square" anchor="t" lIns="0" rIns="0" tIns="0" bIns="0">
+          <a:bodyPr wrap="square" lIns="0" tIns="0" rIns="0" bIns="0" anchor="t">
             <a:spAutoFit/>
           </a:bodyPr>
           <a:lstStyle/>
@@ -8468,9 +8590,9 @@
                 <a:solidFill>
                   <a:srgbClr val="F8FAFC"/>
                 </a:solidFill>
-                <a:latin typeface="Unbounded"/>
-              </a:rPr>
-              <a:t>ПЛАНОМЕТРИКА</a:t>
+                <a:latin typeface="Unbounded Medium"/>
+              </a:rPr>
+              <a:t>Планометрика</a:t>
             </a:r>
           </a:p>
         </p:txBody>
@@ -8492,7 +8614,7 @@
           <a:noFill/>
         </p:spPr>
         <p:txBody>
-          <a:bodyPr wrap="square" anchor="t" lIns="0" rIns="0" tIns="0" bIns="0">
+          <a:bodyPr wrap="square" lIns="0" tIns="0" rIns="0" bIns="0" anchor="t">
             <a:spAutoFit/>
           </a:bodyPr>
           <a:lstStyle/>
@@ -8519,7 +8641,7 @@
         <p:spPr>
           <a:xfrm>
             <a:off x="1554480" y="4297680"/>
-            <a:ext cx="9144000" cy="365760"/>
+            <a:ext cx="9144000" cy="200055"/>
           </a:xfrm>
           <a:prstGeom prst="rect">
             <a:avLst/>
@@ -8527,21 +8649,63 @@
           <a:noFill/>
         </p:spPr>
         <p:txBody>
-          <a:bodyPr wrap="square" anchor="t" lIns="0" rIns="0" tIns="0" bIns="0">
+          <a:bodyPr wrap="square" lIns="0" tIns="0" rIns="0" bIns="0" anchor="t">
             <a:spAutoFit/>
           </a:bodyPr>
           <a:lstStyle/>
           <a:p>
             <a:pPr algn="ctr"/>
             <a:r>
-              <a:rPr sz="1300" b="0">
+              <a:rPr sz="1300" b="0" dirty="0" err="1">
                 <a:solidFill>
                   <a:srgbClr val="92CF93"/>
                 </a:solidFill>
-                <a:latin typeface="JetBrains Mono"/>
-              </a:rPr>
-              <a:t>planometrica.pro · hello@planometrica.pro</a:t>
-            </a:r>
+                <a:latin typeface="JetBrains Mono Medium"/>
+              </a:rPr>
+              <a:t>planometrica.pro</a:t>
+            </a:r>
+            <a:r>
+              <a:rPr sz="1300" b="0" dirty="0">
+                <a:solidFill>
+                  <a:srgbClr val="92CF93"/>
+                </a:solidFill>
+                <a:latin typeface="JetBrains Mono Medium"/>
+              </a:rPr>
+              <a:t> · </a:t>
+            </a:r>
+            <a:r>
+              <a:rPr lang="en-US" sz="1300" dirty="0" err="1">
+                <a:solidFill>
+                  <a:srgbClr val="92CF93"/>
+                </a:solidFill>
+                <a:latin typeface="JetBrains Mono Medium"/>
+              </a:rPr>
+              <a:t>mail</a:t>
+            </a:r>
+            <a:r>
+              <a:rPr sz="1300" b="0" dirty="0" err="1">
+                <a:solidFill>
+                  <a:srgbClr val="92CF93"/>
+                </a:solidFill>
+                <a:latin typeface="JetBrains Mono Medium"/>
+              </a:rPr>
+              <a:t>@planometrica.</a:t>
+            </a:r>
+            <a:r>
+              <a:rPr lang="en-US" sz="1300" dirty="0" err="1">
+                <a:solidFill>
+                  <a:srgbClr val="92CF93"/>
+                </a:solidFill>
+                <a:latin typeface="JetBrains Mono Medium"/>
+              </a:rPr>
+              <a:t>ru</a:t>
+            </a:r>
+            <a:endParaRPr sz="1300" b="0" dirty="0">
+              <a:solidFill>
+                <a:srgbClr val="92CF93"/>
+              </a:solidFill>
+              <a:latin typeface="JetBrains Mono Medium"/>
+            </a:endParaRPr>
           </a:p>
         </p:txBody>
       </p:sp>

</xml_diff>